<commit_message>
Add UI mockup illustrations to training slides
- Generate 5 illustrations: Windows Print dialog, Mac Print dialog,
  iPhone share sheet, PDF document icon, multi-image-to-PDF diagram.
- Wire mockups into title (1), Windows (5), Mac (6), Phone (7), and
  multi-image (8) slides in both the .pptx and PNG previews.
- Visuals make it easier for the audience to find 'Save as PDF' in
  each platform's print UI.
</commit_message>
<xml_diff>
--- a/Save-Images-as-PDF-Using-Print.pptx
+++ b/Save-Images-as-PDF-Using-Print.pptx
@@ -3272,7 +3272,7 @@
         <p:spPr>
           <a:xfrm>
             <a:off x="640080" y="1280160"/>
-            <a:ext cx="10972800" cy="2194560"/>
+            <a:ext cx="7772400" cy="2194560"/>
           </a:xfrm>
           <a:prstGeom prst="rect">
             <a:avLst/>
@@ -3287,7 +3287,7 @@
           <a:p>
             <a:pPr algn="l"/>
             <a:r>
-              <a:rPr sz="6400" b="1">
+              <a:rPr sz="5800" b="1">
                 <a:solidFill>
                   <a:srgbClr val="FF2D87"/>
                 </a:solidFill>
@@ -3307,7 +3307,7 @@
         <p:spPr>
           <a:xfrm>
             <a:off x="640080" y="2468880"/>
-            <a:ext cx="10972800" cy="914400"/>
+            <a:ext cx="7772400" cy="914400"/>
           </a:xfrm>
           <a:prstGeom prst="rect">
             <a:avLst/>
@@ -3322,7 +3322,7 @@
           <a:p>
             <a:pPr algn="l"/>
             <a:r>
-              <a:rPr sz="4400" b="1">
+              <a:rPr sz="4200" b="1">
                 <a:solidFill>
                   <a:srgbClr val="FFD60A"/>
                 </a:solidFill>
@@ -3342,7 +3342,7 @@
         <p:spPr>
           <a:xfrm>
             <a:off x="640080" y="3931920"/>
-            <a:ext cx="10972800" cy="1097280"/>
+            <a:ext cx="7772400" cy="1463040"/>
           </a:xfrm>
           <a:prstGeom prst="rect">
             <a:avLst/>
@@ -3357,7 +3357,7 @@
           <a:p>
             <a:pPr algn="l"/>
             <a:r>
-              <a:rPr sz="2400" b="0">
+              <a:rPr sz="2200" b="0">
                 <a:solidFill>
                   <a:srgbClr val="FAFAFA"/>
                 </a:solidFill>
@@ -3377,7 +3377,7 @@
         <p:spPr>
           <a:xfrm>
             <a:off x="640080" y="5760720"/>
-            <a:ext cx="10972800" cy="548640"/>
+            <a:ext cx="7772400" cy="548640"/>
           </a:xfrm>
           <a:prstGeom prst="rect">
             <a:avLst/>
@@ -3403,6 +3403,30 @@
           </a:p>
         </p:txBody>
       </p:sp>
+      <p:pic>
+        <p:nvPicPr>
+          <p:cNvPr id="10" name="Picture 9" descr="pdf-icon.png"/>
+          <p:cNvPicPr>
+            <a:picLocks noChangeAspect="1"/>
+          </p:cNvPicPr>
+          <p:nvPr/>
+        </p:nvPicPr>
+        <p:blipFill>
+          <a:blip r:embed="rId2"/>
+          <a:stretch>
+            <a:fillRect/>
+          </a:stretch>
+        </p:blipFill>
+        <p:spPr>
+          <a:xfrm>
+            <a:off x="8686800" y="1280160"/>
+            <a:ext cx="3918857" cy="4572000"/>
+          </a:xfrm>
+          <a:prstGeom prst="rect">
+            <a:avLst/>
+          </a:prstGeom>
+        </p:spPr>
+      </p:pic>
     </p:spTree>
   </p:cSld>
   <p:clrMapOvr>
@@ -6303,7 +6327,7 @@
           <a:p>
             <a:pPr algn="l"/>
             <a:r>
-              <a:rPr sz="3800" b="1">
+              <a:rPr sz="3400" b="1">
                 <a:solidFill>
                   <a:srgbClr val="FAFAFA"/>
                 </a:solidFill>
@@ -6323,7 +6347,7 @@
         <p:spPr>
           <a:xfrm>
             <a:off x="640080" y="2194560"/>
-            <a:ext cx="10972800" cy="4206240"/>
+            <a:ext cx="5943600" cy="4206240"/>
           </a:xfrm>
           <a:prstGeom prst="rect">
             <a:avLst/>
@@ -6342,7 +6366,7 @@
               </a:spcAft>
             </a:pPr>
             <a:r>
-              <a:rPr sz="2400" b="1">
+              <a:rPr sz="2000" b="1">
                 <a:solidFill>
                   <a:srgbClr val="FF2D87"/>
                 </a:solidFill>
@@ -6351,7 +6375,7 @@
               <a:t> 1.  </a:t>
             </a:r>
             <a:r>
-              <a:rPr sz="2200">
+              <a:rPr sz="1800">
                 <a:solidFill>
                   <a:srgbClr val="FAFAFA"/>
                 </a:solidFill>
@@ -6367,7 +6391,7 @@
               </a:spcAft>
             </a:pPr>
             <a:r>
-              <a:rPr sz="2400" b="1">
+              <a:rPr sz="2000" b="1">
                 <a:solidFill>
                   <a:srgbClr val="FF2D87"/>
                 </a:solidFill>
@@ -6376,7 +6400,7 @@
               <a:t> 2.  </a:t>
             </a:r>
             <a:r>
-              <a:rPr sz="2200">
+              <a:rPr sz="1800">
                 <a:solidFill>
                   <a:srgbClr val="FAFAFA"/>
                 </a:solidFill>
@@ -6392,7 +6416,7 @@
               </a:spcAft>
             </a:pPr>
             <a:r>
-              <a:rPr sz="2400" b="1">
+              <a:rPr sz="2000" b="1">
                 <a:solidFill>
                   <a:srgbClr val="FF2D87"/>
                 </a:solidFill>
@@ -6401,7 +6425,7 @@
               <a:t> 3.  </a:t>
             </a:r>
             <a:r>
-              <a:rPr sz="2200">
+              <a:rPr sz="1800">
                 <a:solidFill>
                   <a:srgbClr val="FAFAFA"/>
                 </a:solidFill>
@@ -6417,7 +6441,7 @@
               </a:spcAft>
             </a:pPr>
             <a:r>
-              <a:rPr sz="2400" b="1">
+              <a:rPr sz="2000" b="1">
                 <a:solidFill>
                   <a:srgbClr val="FF2D87"/>
                 </a:solidFill>
@@ -6426,7 +6450,7 @@
               <a:t> 4.  </a:t>
             </a:r>
             <a:r>
-              <a:rPr sz="2200">
+              <a:rPr sz="1800">
                 <a:solidFill>
                   <a:srgbClr val="FAFAFA"/>
                 </a:solidFill>
@@ -6442,7 +6466,7 @@
               </a:spcAft>
             </a:pPr>
             <a:r>
-              <a:rPr sz="2400" b="1">
+              <a:rPr sz="2000" b="1">
                 <a:solidFill>
                   <a:srgbClr val="FF2D87"/>
                 </a:solidFill>
@@ -6451,7 +6475,7 @@
               <a:t> 5.  </a:t>
             </a:r>
             <a:r>
-              <a:rPr sz="2200">
+              <a:rPr sz="1800">
                 <a:solidFill>
                   <a:srgbClr val="FAFAFA"/>
                 </a:solidFill>
@@ -6462,6 +6486,30 @@
           </a:p>
         </p:txBody>
       </p:sp>
+      <p:pic>
+        <p:nvPicPr>
+          <p:cNvPr id="8" name="Picture 7" descr="windows-print-dialog.png"/>
+          <p:cNvPicPr>
+            <a:picLocks noChangeAspect="1"/>
+          </p:cNvPicPr>
+          <p:nvPr/>
+        </p:nvPicPr>
+        <p:blipFill>
+          <a:blip r:embed="rId2"/>
+          <a:stretch>
+            <a:fillRect/>
+          </a:stretch>
+        </p:blipFill>
+        <p:spPr>
+          <a:xfrm>
+            <a:off x="6583680" y="1828800"/>
+            <a:ext cx="5212080" cy="3553691"/>
+          </a:xfrm>
+          <a:prstGeom prst="rect">
+            <a:avLst/>
+          </a:prstGeom>
+        </p:spPr>
+      </p:pic>
     </p:spTree>
   </p:cSld>
   <p:clrMapOvr>
@@ -6668,7 +6716,7 @@
           <a:p>
             <a:pPr algn="l"/>
             <a:r>
-              <a:rPr sz="3800" b="1">
+              <a:rPr sz="3400" b="1">
                 <a:solidFill>
                   <a:srgbClr val="FAFAFA"/>
                 </a:solidFill>
@@ -6688,7 +6736,7 @@
         <p:spPr>
           <a:xfrm>
             <a:off x="640080" y="2194560"/>
-            <a:ext cx="10972800" cy="4206240"/>
+            <a:ext cx="5943600" cy="4206240"/>
           </a:xfrm>
           <a:prstGeom prst="rect">
             <a:avLst/>
@@ -6707,7 +6755,7 @@
               </a:spcAft>
             </a:pPr>
             <a:r>
-              <a:rPr sz="2400" b="1">
+              <a:rPr sz="2000" b="1">
                 <a:solidFill>
                   <a:srgbClr val="FF2D87"/>
                 </a:solidFill>
@@ -6716,7 +6764,7 @@
               <a:t> 1.  </a:t>
             </a:r>
             <a:r>
-              <a:rPr sz="2200">
+              <a:rPr sz="1800">
                 <a:solidFill>
                   <a:srgbClr val="FAFAFA"/>
                 </a:solidFill>
@@ -6732,7 +6780,7 @@
               </a:spcAft>
             </a:pPr>
             <a:r>
-              <a:rPr sz="2400" b="1">
+              <a:rPr sz="2000" b="1">
                 <a:solidFill>
                   <a:srgbClr val="FF2D87"/>
                 </a:solidFill>
@@ -6741,7 +6789,7 @@
               <a:t> 2.  </a:t>
             </a:r>
             <a:r>
-              <a:rPr sz="2200">
+              <a:rPr sz="1800">
                 <a:solidFill>
                   <a:srgbClr val="FAFAFA"/>
                 </a:solidFill>
@@ -6757,7 +6805,7 @@
               </a:spcAft>
             </a:pPr>
             <a:r>
-              <a:rPr sz="2400" b="1">
+              <a:rPr sz="2000" b="1">
                 <a:solidFill>
                   <a:srgbClr val="FF2D87"/>
                 </a:solidFill>
@@ -6766,7 +6814,7 @@
               <a:t> 3.  </a:t>
             </a:r>
             <a:r>
-              <a:rPr sz="2200">
+              <a:rPr sz="1800">
                 <a:solidFill>
                   <a:srgbClr val="FAFAFA"/>
                 </a:solidFill>
@@ -6782,7 +6830,7 @@
               </a:spcAft>
             </a:pPr>
             <a:r>
-              <a:rPr sz="2400" b="1">
+              <a:rPr sz="2000" b="1">
                 <a:solidFill>
                   <a:srgbClr val="FF2D87"/>
                 </a:solidFill>
@@ -6791,7 +6839,7 @@
               <a:t> 4.  </a:t>
             </a:r>
             <a:r>
-              <a:rPr sz="2200">
+              <a:rPr sz="1800">
                 <a:solidFill>
                   <a:srgbClr val="FAFAFA"/>
                 </a:solidFill>
@@ -6807,7 +6855,7 @@
               </a:spcAft>
             </a:pPr>
             <a:r>
-              <a:rPr sz="2400" b="1">
+              <a:rPr sz="2000" b="1">
                 <a:solidFill>
                   <a:srgbClr val="FF2D87"/>
                 </a:solidFill>
@@ -6816,7 +6864,7 @@
               <a:t> 5.  </a:t>
             </a:r>
             <a:r>
-              <a:rPr sz="2200">
+              <a:rPr sz="1800">
                 <a:solidFill>
                   <a:srgbClr val="FAFAFA"/>
                 </a:solidFill>
@@ -6827,16 +6875,40 @@
           </a:p>
         </p:txBody>
       </p:sp>
-      <p:sp>
-        <p:nvSpPr>
-          <p:cNvPr id="8" name="TextBox 7"/>
+      <p:pic>
+        <p:nvPicPr>
+          <p:cNvPr id="8" name="Picture 7" descr="mac-print-dialog.png"/>
+          <p:cNvPicPr>
+            <a:picLocks noChangeAspect="1"/>
+          </p:cNvPicPr>
+          <p:nvPr/>
+        </p:nvPicPr>
+        <p:blipFill>
+          <a:blip r:embed="rId2"/>
+          <a:stretch>
+            <a:fillRect/>
+          </a:stretch>
+        </p:blipFill>
+        <p:spPr>
+          <a:xfrm>
+            <a:off x="6583680" y="1828800"/>
+            <a:ext cx="5212080" cy="3553691"/>
+          </a:xfrm>
+          <a:prstGeom prst="rect">
+            <a:avLst/>
+          </a:prstGeom>
+        </p:spPr>
+      </p:pic>
+      <p:sp>
+        <p:nvSpPr>
+          <p:cNvPr id="9" name="TextBox 8"/>
           <p:cNvSpPr txBox="1"/>
           <p:nvPr/>
         </p:nvSpPr>
         <p:spPr>
           <a:xfrm>
-            <a:off x="640080" y="5943600"/>
-            <a:ext cx="10972800" cy="548640"/>
+            <a:off x="640080" y="6126480"/>
+            <a:ext cx="11430000" cy="457200"/>
           </a:xfrm>
           <a:prstGeom prst="rect">
             <a:avLst/>
@@ -6851,13 +6923,13 @@
           <a:p>
             <a:pPr algn="l"/>
             <a:r>
-              <a:rPr sz="1600" b="1">
+              <a:rPr sz="1400" b="1">
                 <a:solidFill>
                   <a:srgbClr val="FFD60A"/>
                 </a:solidFill>
                 <a:latin typeface="Calibri"/>
               </a:rPr>
-              <a:t>Bonus: select multiple images in Finder, right-click → Quick Actions → Create PDF.</a:t>
+              <a:t>Bonus: in Finder, select images → right-click → Quick Actions → Create PDF.</a:t>
             </a:r>
           </a:p>
         </p:txBody>
@@ -7068,7 +7140,7 @@
           <a:p>
             <a:pPr algn="l"/>
             <a:r>
-              <a:rPr sz="3800" b="1">
+              <a:rPr sz="3200" b="1">
                 <a:solidFill>
                   <a:srgbClr val="FAFAFA"/>
                 </a:solidFill>
@@ -7088,7 +7160,7 @@
         <p:spPr>
           <a:xfrm>
             <a:off x="640080" y="2194560"/>
-            <a:ext cx="10972800" cy="4206240"/>
+            <a:ext cx="7315200" cy="4206240"/>
           </a:xfrm>
           <a:prstGeom prst="rect">
             <a:avLst/>
@@ -7107,7 +7179,7 @@
               </a:spcAft>
             </a:pPr>
             <a:r>
-              <a:rPr sz="2400" b="1">
+              <a:rPr sz="2000" b="1">
                 <a:solidFill>
                   <a:srgbClr val="FF2D87"/>
                 </a:solidFill>
@@ -7116,7 +7188,7 @@
               <a:t> 1.  </a:t>
             </a:r>
             <a:r>
-              <a:rPr sz="2200">
+              <a:rPr sz="1800">
                 <a:solidFill>
                   <a:srgbClr val="FAFAFA"/>
                 </a:solidFill>
@@ -7132,7 +7204,7 @@
               </a:spcAft>
             </a:pPr>
             <a:r>
-              <a:rPr sz="2400" b="1">
+              <a:rPr sz="2000" b="1">
                 <a:solidFill>
                   <a:srgbClr val="FF2D87"/>
                 </a:solidFill>
@@ -7141,7 +7213,7 @@
               <a:t> 2.  </a:t>
             </a:r>
             <a:r>
-              <a:rPr sz="2200">
+              <a:rPr sz="1800">
                 <a:solidFill>
                   <a:srgbClr val="FAFAFA"/>
                 </a:solidFill>
@@ -7157,7 +7229,7 @@
               </a:spcAft>
             </a:pPr>
             <a:r>
-              <a:rPr sz="2400" b="1">
+              <a:rPr sz="2000" b="1">
                 <a:solidFill>
                   <a:srgbClr val="FF2D87"/>
                 </a:solidFill>
@@ -7166,7 +7238,7 @@
               <a:t> 3.  </a:t>
             </a:r>
             <a:r>
-              <a:rPr sz="2200">
+              <a:rPr sz="1800">
                 <a:solidFill>
                   <a:srgbClr val="FAFAFA"/>
                 </a:solidFill>
@@ -7182,7 +7254,7 @@
               </a:spcAft>
             </a:pPr>
             <a:r>
-              <a:rPr sz="2400" b="1">
+              <a:rPr sz="2000" b="1">
                 <a:solidFill>
                   <a:srgbClr val="FF2D87"/>
                 </a:solidFill>
@@ -7191,13 +7263,13 @@
               <a:t> 4.  </a:t>
             </a:r>
             <a:r>
-              <a:rPr sz="2200">
+              <a:rPr sz="1800">
                 <a:solidFill>
                   <a:srgbClr val="FAFAFA"/>
                 </a:solidFill>
                 <a:latin typeface="Calibri"/>
               </a:rPr>
-              <a:t>On the print preview, pinch out with two fingers (iPhone) or tap the PDF icon (Android).</a:t>
+              <a:t>Pinch out with two fingers on the preview (iPhone) or tap the PDF icon (Android).</a:t>
             </a:r>
           </a:p>
           <a:p>
@@ -7207,7 +7279,7 @@
               </a:spcAft>
             </a:pPr>
             <a:r>
-              <a:rPr sz="2400" b="1">
+              <a:rPr sz="2000" b="1">
                 <a:solidFill>
                   <a:srgbClr val="FF2D87"/>
                 </a:solidFill>
@@ -7216,7 +7288,7 @@
               <a:t> 5.  </a:t>
             </a:r>
             <a:r>
-              <a:rPr sz="2200">
+              <a:rPr sz="1800">
                 <a:solidFill>
                   <a:srgbClr val="FAFAFA"/>
                 </a:solidFill>
@@ -7227,6 +7299,30 @@
           </a:p>
         </p:txBody>
       </p:sp>
+      <p:pic>
+        <p:nvPicPr>
+          <p:cNvPr id="8" name="Picture 7" descr="iphone-share-sheet.png"/>
+          <p:cNvPicPr>
+            <a:picLocks noChangeAspect="1"/>
+          </p:cNvPicPr>
+          <p:nvPr/>
+        </p:nvPicPr>
+        <p:blipFill>
+          <a:blip r:embed="rId2"/>
+          <a:stretch>
+            <a:fillRect/>
+          </a:stretch>
+        </p:blipFill>
+        <p:spPr>
+          <a:xfrm>
+            <a:off x="8229600" y="1463040"/>
+            <a:ext cx="3724102" cy="5120640"/>
+          </a:xfrm>
+          <a:prstGeom prst="rect">
+            <a:avLst/>
+          </a:prstGeom>
+        </p:spPr>
+      </p:pic>
     </p:spTree>
   </p:cSld>
   <p:clrMapOvr>
@@ -7433,7 +7529,7 @@
           <a:p>
             <a:pPr algn="l"/>
             <a:r>
-              <a:rPr sz="3800" b="1">
+              <a:rPr sz="3600" b="1">
                 <a:solidFill>
                   <a:srgbClr val="FAFAFA"/>
                 </a:solidFill>
@@ -7444,15 +7540,39 @@
           </a:p>
         </p:txBody>
       </p:sp>
-      <p:sp>
-        <p:nvSpPr>
-          <p:cNvPr id="7" name="TextBox 6"/>
+      <p:pic>
+        <p:nvPicPr>
+          <p:cNvPr id="7" name="Picture 6" descr="multi-to-one.png"/>
+          <p:cNvPicPr>
+            <a:picLocks noChangeAspect="1"/>
+          </p:cNvPicPr>
+          <p:nvPr/>
+        </p:nvPicPr>
+        <p:blipFill>
+          <a:blip r:embed="rId2"/>
+          <a:stretch>
+            <a:fillRect/>
+          </a:stretch>
+        </p:blipFill>
+        <p:spPr>
+          <a:xfrm>
+            <a:off x="2286000" y="1737360"/>
+            <a:ext cx="7772400" cy="3886200"/>
+          </a:xfrm>
+          <a:prstGeom prst="rect">
+            <a:avLst/>
+          </a:prstGeom>
+        </p:spPr>
+      </p:pic>
+      <p:sp>
+        <p:nvSpPr>
+          <p:cNvPr id="8" name="TextBox 7"/>
           <p:cNvSpPr txBox="1"/>
           <p:nvPr/>
         </p:nvSpPr>
         <p:spPr>
           <a:xfrm>
-            <a:off x="640080" y="2377440"/>
+            <a:off x="640080" y="5029200"/>
             <a:ext cx="10972800" cy="4023360"/>
           </a:xfrm>
           <a:prstGeom prst="rect">
@@ -7472,13 +7592,13 @@
               </a:spcAft>
             </a:pPr>
             <a:r>
-              <a:rPr sz="2200">
+              <a:rPr sz="1800">
                 <a:solidFill>
                   <a:srgbClr val="FAFAFA"/>
                 </a:solidFill>
                 <a:latin typeface="Calibri"/>
               </a:rPr>
-              <a:t>• Windows: select all images in File Explorer → right-click → Print → "Microsoft Print to PDF."</a:t>
+              <a:t>• Windows: File Explorer → select images → right-click → Print → "Microsoft Print to PDF."</a:t>
             </a:r>
           </a:p>
           <a:p>
@@ -7488,13 +7608,13 @@
               </a:spcAft>
             </a:pPr>
             <a:r>
-              <a:rPr sz="2200">
+              <a:rPr sz="1800">
                 <a:solidFill>
                   <a:srgbClr val="FAFAFA"/>
                 </a:solidFill>
                 <a:latin typeface="Calibri"/>
               </a:rPr>
-              <a:t>• Mac: select images in Finder → right-click → Quick Actions → Create PDF.</a:t>
+              <a:t>• Mac: Finder → select images → right-click → Quick Actions → Create PDF.</a:t>
             </a:r>
           </a:p>
           <a:p>
@@ -7504,27 +7624,27 @@
               </a:spcAft>
             </a:pPr>
             <a:r>
-              <a:rPr sz="2200">
+              <a:rPr sz="1800">
                 <a:solidFill>
                   <a:srgbClr val="FAFAFA"/>
                 </a:solidFill>
                 <a:latin typeface="Calibri"/>
               </a:rPr>
-              <a:t>• Phone: in Photos, tap Select, choose your images, then Share → Print → pinch out.</a:t>
-            </a:r>
-          </a:p>
-        </p:txBody>
-      </p:sp>
-      <p:sp>
-        <p:nvSpPr>
-          <p:cNvPr id="8" name="TextBox 7"/>
+              <a:t>• Phone: Photos → Select → Share → Print → pinch out.</a:t>
+            </a:r>
+          </a:p>
+        </p:txBody>
+      </p:sp>
+      <p:sp>
+        <p:nvSpPr>
+          <p:cNvPr id="9" name="TextBox 8"/>
           <p:cNvSpPr txBox="1"/>
           <p:nvPr/>
         </p:nvSpPr>
         <p:spPr>
           <a:xfrm>
-            <a:off x="640080" y="5760720"/>
-            <a:ext cx="10972800" cy="548640"/>
+            <a:off x="640080" y="6263640"/>
+            <a:ext cx="10972800" cy="457200"/>
           </a:xfrm>
           <a:prstGeom prst="rect">
             <a:avLst/>
@@ -7539,7 +7659,7 @@
           <a:p>
             <a:pPr algn="l"/>
             <a:r>
-              <a:rPr sz="1800" b="1">
+              <a:rPr sz="1500" b="1">
                 <a:solidFill>
                   <a:srgbClr val="FFD60A"/>
                 </a:solidFill>

</xml_diff>

<commit_message>
Add 'Shortcut: Export to PDF' slide
New slide 9 covers the one-step Export → PDF path that some apps
(Office, iWork, Photos, Google Docs) offer as an alternative to the
Print-to-PDF method. Deck is now 13 slides; comments/numbering and
contact-sheet grid updated to match.
</commit_message>
<xml_diff>
--- a/Save-Images-as-PDF-Using-Print.pptx
+++ b/Save-Images-as-PDF-Using-Print.pptx
@@ -17,6 +17,7 @@
     <p:sldId id="265" r:id="rId16"/>
     <p:sldId id="266" r:id="rId17"/>
     <p:sldId id="267" r:id="rId18"/>
+    <p:sldId id="268" r:id="rId19"/>
   </p:sldIdLst>
   <p:sldSz cx="12191695" cy="6858000" type="screen4x3"/>
   <p:notesSz cx="6858000" cy="9144000"/>
@@ -3604,7 +3605,7 @@
                 </a:solidFill>
                 <a:latin typeface="Calibri"/>
               </a:rPr>
-              <a:t>WATCH OUT FOR</a:t>
+              <a:t>YOUR TURN</a:t>
             </a:r>
           </a:p>
         </p:txBody>
@@ -3633,72 +3634,27 @@
           <a:p>
             <a:pPr algn="l"/>
             <a:r>
-              <a:rPr sz="3800" b="1">
+              <a:rPr sz="4400" b="1">
                 <a:solidFill>
                   <a:srgbClr val="FAFAFA"/>
                 </a:solidFill>
                 <a:latin typeface="Calibri"/>
               </a:rPr>
-              <a:t>Three things that trip people up</a:t>
-            </a:r>
-          </a:p>
-        </p:txBody>
-      </p:sp>
-      <p:sp>
-        <p:nvSpPr>
-          <p:cNvPr id="7" name="Rounded Rectangle 6"/>
-          <p:cNvSpPr/>
+              <a:t>Try it with me — 60 seconds.</a:t>
+            </a:r>
+          </a:p>
+        </p:txBody>
+      </p:sp>
+      <p:sp>
+        <p:nvSpPr>
+          <p:cNvPr id="7" name="TextBox 6"/>
+          <p:cNvSpPr txBox="1"/>
           <p:nvPr/>
         </p:nvSpPr>
         <p:spPr>
           <a:xfrm>
             <a:off x="640080" y="2377440"/>
-            <a:ext cx="5440680" cy="1874519"/>
-          </a:xfrm>
-          <a:prstGeom prst="roundRect">
-            <a:avLst/>
-          </a:prstGeom>
-          <a:solidFill>
-            <a:srgbClr val="1C1C26"/>
-          </a:solidFill>
-          <a:ln w="19050">
-            <a:solidFill>
-              <a:srgbClr val="FF2D87"/>
-            </a:solidFill>
-          </a:ln>
-        </p:spPr>
-        <p:style>
-          <a:lnRef idx="1">
-            <a:schemeClr val="accent1"/>
-          </a:lnRef>
-          <a:fillRef idx="3">
-            <a:schemeClr val="accent1"/>
-          </a:fillRef>
-          <a:effectRef idx="2">
-            <a:schemeClr val="accent1"/>
-          </a:effectRef>
-          <a:fontRef idx="minor">
-            <a:schemeClr val="lt1"/>
-          </a:fontRef>
-        </p:style>
-        <p:txBody>
-          <a:bodyPr rtlCol="0" anchor="ctr"/>
-          <a:lstStyle/>
-          <a:p>
-            <a:pPr algn="ctr"/>
-          </a:p>
-        </p:txBody>
-      </p:sp>
-      <p:sp>
-        <p:nvSpPr>
-          <p:cNvPr id="8" name="TextBox 7"/>
-          <p:cNvSpPr txBox="1"/>
-          <p:nvPr/>
-        </p:nvSpPr>
-        <p:spPr>
-          <a:xfrm>
-            <a:off x="868680" y="2542032"/>
-            <a:ext cx="5029200" cy="457200"/>
+            <a:ext cx="10972800" cy="4023360"/>
           </a:xfrm>
           <a:prstGeom prst="rect">
             <a:avLst/>
@@ -3711,29 +3667,81 @@
           </a:bodyPr>
           <a:lstStyle/>
           <a:p>
-            <a:pPr algn="l"/>
-            <a:r>
-              <a:rPr sz="2000" b="1">
-                <a:solidFill>
-                  <a:srgbClr val="FF2D87"/>
-                </a:solidFill>
-                <a:latin typeface="Calibri"/>
-              </a:rPr>
-              <a:t>1. Wrong destination</a:t>
-            </a:r>
-          </a:p>
-        </p:txBody>
-      </p:sp>
-      <p:sp>
-        <p:nvSpPr>
-          <p:cNvPr id="9" name="TextBox 8"/>
+            <a:pPr algn="l">
+              <a:spcAft>
+                <a:spcPts val="800"/>
+              </a:spcAft>
+            </a:pPr>
+            <a:r>
+              <a:rPr sz="2200">
+                <a:solidFill>
+                  <a:srgbClr val="FAFAFA"/>
+                </a:solidFill>
+                <a:latin typeface="Calibri"/>
+              </a:rPr>
+              <a:t>• Pick any photo on your device.</a:t>
+            </a:r>
+          </a:p>
+          <a:p>
+            <a:pPr algn="l">
+              <a:spcAft>
+                <a:spcPts val="800"/>
+              </a:spcAft>
+            </a:pPr>
+            <a:r>
+              <a:rPr sz="2200">
+                <a:solidFill>
+                  <a:srgbClr val="FAFAFA"/>
+                </a:solidFill>
+                <a:latin typeface="Calibri"/>
+              </a:rPr>
+              <a:t>• Open it. Hit Print.</a:t>
+            </a:r>
+          </a:p>
+          <a:p>
+            <a:pPr algn="l">
+              <a:spcAft>
+                <a:spcPts val="800"/>
+              </a:spcAft>
+            </a:pPr>
+            <a:r>
+              <a:rPr sz="2200">
+                <a:solidFill>
+                  <a:srgbClr val="FAFAFA"/>
+                </a:solidFill>
+                <a:latin typeface="Calibri"/>
+              </a:rPr>
+              <a:t>• Choose "Save as PDF."</a:t>
+            </a:r>
+          </a:p>
+          <a:p>
+            <a:pPr algn="l">
+              <a:spcAft>
+                <a:spcPts val="800"/>
+              </a:spcAft>
+            </a:pPr>
+            <a:r>
+              <a:rPr sz="2200">
+                <a:solidFill>
+                  <a:srgbClr val="FAFAFA"/>
+                </a:solidFill>
+                <a:latin typeface="Calibri"/>
+              </a:rPr>
+              <a:t>• Save it to your Desktop as test.pdf.</a:t>
+            </a:r>
+          </a:p>
+        </p:txBody>
+      </p:sp>
+      <p:sp>
+        <p:nvSpPr>
+          <p:cNvPr id="8" name="TextBox 7"/>
           <p:cNvSpPr txBox="1"/>
           <p:nvPr/>
         </p:nvSpPr>
         <p:spPr>
           <a:xfrm>
-            <a:off x="868680" y="3154680"/>
-            <a:ext cx="5029200" cy="1005840"/>
+            <a:off x="640080" y="5852160"/>
+            <a:ext cx="10972800" cy="548640"/>
           </a:xfrm>
           <a:prstGeom prst="rect">
             <a:avLst/>
@@ -3748,358 +3756,13 @@
           <a:p>
             <a:pPr algn="l"/>
             <a:r>
-              <a:rPr sz="1600" b="0">
+              <a:rPr sz="1800" b="0">
                 <a:solidFill>
                   <a:srgbClr val="FAFAFA"/>
                 </a:solidFill>
                 <a:latin typeface="Calibri"/>
               </a:rPr>
-              <a:t>If your real printer is selected, it'll print on paper. Always switch the destination to Save as PDF.</a:t>
-            </a:r>
-          </a:p>
-        </p:txBody>
-      </p:sp>
-      <p:sp>
-        <p:nvSpPr>
-          <p:cNvPr id="10" name="Rounded Rectangle 9"/>
-          <p:cNvSpPr/>
-          <p:nvPr/>
-        </p:nvSpPr>
-        <p:spPr>
-          <a:xfrm>
-            <a:off x="6355080" y="2377440"/>
-            <a:ext cx="5440680" cy="1874519"/>
-          </a:xfrm>
-          <a:prstGeom prst="roundRect">
-            <a:avLst/>
-          </a:prstGeom>
-          <a:solidFill>
-            <a:srgbClr val="1C1C26"/>
-          </a:solidFill>
-          <a:ln w="19050">
-            <a:solidFill>
-              <a:srgbClr val="FF2D87"/>
-            </a:solidFill>
-          </a:ln>
-        </p:spPr>
-        <p:style>
-          <a:lnRef idx="1">
-            <a:schemeClr val="accent1"/>
-          </a:lnRef>
-          <a:fillRef idx="3">
-            <a:schemeClr val="accent1"/>
-          </a:fillRef>
-          <a:effectRef idx="2">
-            <a:schemeClr val="accent1"/>
-          </a:effectRef>
-          <a:fontRef idx="minor">
-            <a:schemeClr val="lt1"/>
-          </a:fontRef>
-        </p:style>
-        <p:txBody>
-          <a:bodyPr rtlCol="0" anchor="ctr"/>
-          <a:lstStyle/>
-          <a:p>
-            <a:pPr algn="ctr"/>
-          </a:p>
-        </p:txBody>
-      </p:sp>
-      <p:sp>
-        <p:nvSpPr>
-          <p:cNvPr id="11" name="TextBox 10"/>
-          <p:cNvSpPr txBox="1"/>
-          <p:nvPr/>
-        </p:nvSpPr>
-        <p:spPr>
-          <a:xfrm>
-            <a:off x="6583680" y="2542032"/>
-            <a:ext cx="5029200" cy="457200"/>
-          </a:xfrm>
-          <a:prstGeom prst="rect">
-            <a:avLst/>
-          </a:prstGeom>
-          <a:noFill/>
-        </p:spPr>
-        <p:txBody>
-          <a:bodyPr wrap="square">
-            <a:spAutoFit/>
-          </a:bodyPr>
-          <a:lstStyle/>
-          <a:p>
-            <a:pPr algn="l"/>
-            <a:r>
-              <a:rPr sz="2000" b="1">
-                <a:solidFill>
-                  <a:srgbClr val="FF2D87"/>
-                </a:solidFill>
-                <a:latin typeface="Calibri"/>
-              </a:rPr>
-              <a:t>2. Cropped image</a:t>
-            </a:r>
-          </a:p>
-        </p:txBody>
-      </p:sp>
-      <p:sp>
-        <p:nvSpPr>
-          <p:cNvPr id="12" name="TextBox 11"/>
-          <p:cNvSpPr txBox="1"/>
-          <p:nvPr/>
-        </p:nvSpPr>
-        <p:spPr>
-          <a:xfrm>
-            <a:off x="6583680" y="3154680"/>
-            <a:ext cx="5029200" cy="1005840"/>
-          </a:xfrm>
-          <a:prstGeom prst="rect">
-            <a:avLst/>
-          </a:prstGeom>
-          <a:noFill/>
-        </p:spPr>
-        <p:txBody>
-          <a:bodyPr wrap="square">
-            <a:spAutoFit/>
-          </a:bodyPr>
-          <a:lstStyle/>
-          <a:p>
-            <a:pPr algn="l"/>
-            <a:r>
-              <a:rPr sz="1600" b="0">
-                <a:solidFill>
-                  <a:srgbClr val="FAFAFA"/>
-                </a:solidFill>
-                <a:latin typeface="Calibri"/>
-              </a:rPr>
-              <a:t>If the photo is cut off, change orientation to Landscape or shrink margins to None.</a:t>
-            </a:r>
-          </a:p>
-        </p:txBody>
-      </p:sp>
-      <p:sp>
-        <p:nvSpPr>
-          <p:cNvPr id="13" name="Rounded Rectangle 12"/>
-          <p:cNvSpPr/>
-          <p:nvPr/>
-        </p:nvSpPr>
-        <p:spPr>
-          <a:xfrm>
-            <a:off x="640080" y="4526280"/>
-            <a:ext cx="5440680" cy="1874519"/>
-          </a:xfrm>
-          <a:prstGeom prst="roundRect">
-            <a:avLst/>
-          </a:prstGeom>
-          <a:solidFill>
-            <a:srgbClr val="1C1C26"/>
-          </a:solidFill>
-          <a:ln w="19050">
-            <a:solidFill>
-              <a:srgbClr val="FF2D87"/>
-            </a:solidFill>
-          </a:ln>
-        </p:spPr>
-        <p:style>
-          <a:lnRef idx="1">
-            <a:schemeClr val="accent1"/>
-          </a:lnRef>
-          <a:fillRef idx="3">
-            <a:schemeClr val="accent1"/>
-          </a:fillRef>
-          <a:effectRef idx="2">
-            <a:schemeClr val="accent1"/>
-          </a:effectRef>
-          <a:fontRef idx="minor">
-            <a:schemeClr val="lt1"/>
-          </a:fontRef>
-        </p:style>
-        <p:txBody>
-          <a:bodyPr rtlCol="0" anchor="ctr"/>
-          <a:lstStyle/>
-          <a:p>
-            <a:pPr algn="ctr"/>
-          </a:p>
-        </p:txBody>
-      </p:sp>
-      <p:sp>
-        <p:nvSpPr>
-          <p:cNvPr id="14" name="TextBox 13"/>
-          <p:cNvSpPr txBox="1"/>
-          <p:nvPr/>
-        </p:nvSpPr>
-        <p:spPr>
-          <a:xfrm>
-            <a:off x="868680" y="4690872"/>
-            <a:ext cx="5029200" cy="457200"/>
-          </a:xfrm>
-          <a:prstGeom prst="rect">
-            <a:avLst/>
-          </a:prstGeom>
-          <a:noFill/>
-        </p:spPr>
-        <p:txBody>
-          <a:bodyPr wrap="square">
-            <a:spAutoFit/>
-          </a:bodyPr>
-          <a:lstStyle/>
-          <a:p>
-            <a:pPr algn="l"/>
-            <a:r>
-              <a:rPr sz="2000" b="1">
-                <a:solidFill>
-                  <a:srgbClr val="FF2D87"/>
-                </a:solidFill>
-                <a:latin typeface="Calibri"/>
-              </a:rPr>
-              <a:t>3. Lost file</a:t>
-            </a:r>
-          </a:p>
-        </p:txBody>
-      </p:sp>
-      <p:sp>
-        <p:nvSpPr>
-          <p:cNvPr id="15" name="TextBox 14"/>
-          <p:cNvSpPr txBox="1"/>
-          <p:nvPr/>
-        </p:nvSpPr>
-        <p:spPr>
-          <a:xfrm>
-            <a:off x="868680" y="5303520"/>
-            <a:ext cx="5029200" cy="1005840"/>
-          </a:xfrm>
-          <a:prstGeom prst="rect">
-            <a:avLst/>
-          </a:prstGeom>
-          <a:noFill/>
-        </p:spPr>
-        <p:txBody>
-          <a:bodyPr wrap="square">
-            <a:spAutoFit/>
-          </a:bodyPr>
-          <a:lstStyle/>
-          <a:p>
-            <a:pPr algn="l"/>
-            <a:r>
-              <a:rPr sz="1600" b="0">
-                <a:solidFill>
-                  <a:srgbClr val="FAFAFA"/>
-                </a:solidFill>
-                <a:latin typeface="Calibri"/>
-              </a:rPr>
-              <a:t>Note the folder before you click Save. Default is usually Documents or Downloads.</a:t>
-            </a:r>
-          </a:p>
-        </p:txBody>
-      </p:sp>
-      <p:sp>
-        <p:nvSpPr>
-          <p:cNvPr id="16" name="Rounded Rectangle 15"/>
-          <p:cNvSpPr/>
-          <p:nvPr/>
-        </p:nvSpPr>
-        <p:spPr>
-          <a:xfrm>
-            <a:off x="6355080" y="4526280"/>
-            <a:ext cx="5440680" cy="1874519"/>
-          </a:xfrm>
-          <a:prstGeom prst="roundRect">
-            <a:avLst/>
-          </a:prstGeom>
-          <a:solidFill>
-            <a:srgbClr val="1C1C26"/>
-          </a:solidFill>
-          <a:ln w="19050">
-            <a:solidFill>
-              <a:srgbClr val="FF2D87"/>
-            </a:solidFill>
-          </a:ln>
-        </p:spPr>
-        <p:style>
-          <a:lnRef idx="1">
-            <a:schemeClr val="accent1"/>
-          </a:lnRef>
-          <a:fillRef idx="3">
-            <a:schemeClr val="accent1"/>
-          </a:fillRef>
-          <a:effectRef idx="2">
-            <a:schemeClr val="accent1"/>
-          </a:effectRef>
-          <a:fontRef idx="minor">
-            <a:schemeClr val="lt1"/>
-          </a:fontRef>
-        </p:style>
-        <p:txBody>
-          <a:bodyPr rtlCol="0" anchor="ctr"/>
-          <a:lstStyle/>
-          <a:p>
-            <a:pPr algn="ctr"/>
-          </a:p>
-        </p:txBody>
-      </p:sp>
-      <p:sp>
-        <p:nvSpPr>
-          <p:cNvPr id="17" name="TextBox 16"/>
-          <p:cNvSpPr txBox="1"/>
-          <p:nvPr/>
-        </p:nvSpPr>
-        <p:spPr>
-          <a:xfrm>
-            <a:off x="6583680" y="4690872"/>
-            <a:ext cx="5029200" cy="457200"/>
-          </a:xfrm>
-          <a:prstGeom prst="rect">
-            <a:avLst/>
-          </a:prstGeom>
-          <a:noFill/>
-        </p:spPr>
-        <p:txBody>
-          <a:bodyPr wrap="square">
-            <a:spAutoFit/>
-          </a:bodyPr>
-          <a:lstStyle/>
-          <a:p>
-            <a:pPr algn="l"/>
-            <a:r>
-              <a:rPr sz="2000" b="1">
-                <a:solidFill>
-                  <a:srgbClr val="FF2D87"/>
-                </a:solidFill>
-                <a:latin typeface="Calibri"/>
-              </a:rPr>
-              <a:t>Bonus: huge file size</a:t>
-            </a:r>
-          </a:p>
-        </p:txBody>
-      </p:sp>
-      <p:sp>
-        <p:nvSpPr>
-          <p:cNvPr id="18" name="TextBox 17"/>
-          <p:cNvSpPr txBox="1"/>
-          <p:nvPr/>
-        </p:nvSpPr>
-        <p:spPr>
-          <a:xfrm>
-            <a:off x="6583680" y="5303520"/>
-            <a:ext cx="5029200" cy="1005840"/>
-          </a:xfrm>
-          <a:prstGeom prst="rect">
-            <a:avLst/>
-          </a:prstGeom>
-          <a:noFill/>
-        </p:spPr>
-        <p:txBody>
-          <a:bodyPr wrap="square">
-            <a:spAutoFit/>
-          </a:bodyPr>
-          <a:lstStyle/>
-          <a:p>
-            <a:pPr algn="l"/>
-            <a:r>
-              <a:rPr sz="1600" b="0">
-                <a:solidFill>
-                  <a:srgbClr val="FAFAFA"/>
-                </a:solidFill>
-                <a:latin typeface="Calibri"/>
-              </a:rPr>
-              <a:t>If the PDF is too big to email, lower print quality to Standard or use a smaller paper size.</a:t>
+              <a:t>Raise your hand if you get stuck — I'll come help.</a:t>
             </a:r>
           </a:p>
         </p:txBody>
@@ -4281,7 +3944,7 @@
                 </a:solidFill>
                 <a:latin typeface="Calibri"/>
               </a:rPr>
-              <a:t>QUICK RECAP</a:t>
+              <a:t>WATCH OUT FOR</a:t>
             </a:r>
           </a:p>
         </p:txBody>
@@ -4310,27 +3973,72 @@
           <a:p>
             <a:pPr algn="l"/>
             <a:r>
-              <a:rPr sz="4000" b="1">
+              <a:rPr sz="3800" b="1">
                 <a:solidFill>
                   <a:srgbClr val="FAFAFA"/>
                 </a:solidFill>
                 <a:latin typeface="Calibri"/>
               </a:rPr>
-              <a:t>The whole skill in five words:</a:t>
-            </a:r>
-          </a:p>
-        </p:txBody>
-      </p:sp>
-      <p:sp>
-        <p:nvSpPr>
-          <p:cNvPr id="7" name="TextBox 6"/>
+              <a:t>Three things that trip people up</a:t>
+            </a:r>
+          </a:p>
+        </p:txBody>
+      </p:sp>
+      <p:sp>
+        <p:nvSpPr>
+          <p:cNvPr id="7" name="Rounded Rectangle 6"/>
+          <p:cNvSpPr/>
+          <p:nvPr/>
+        </p:nvSpPr>
+        <p:spPr>
+          <a:xfrm>
+            <a:off x="640080" y="2377440"/>
+            <a:ext cx="5440680" cy="1874519"/>
+          </a:xfrm>
+          <a:prstGeom prst="roundRect">
+            <a:avLst/>
+          </a:prstGeom>
+          <a:solidFill>
+            <a:srgbClr val="1C1C26"/>
+          </a:solidFill>
+          <a:ln w="19050">
+            <a:solidFill>
+              <a:srgbClr val="FF2D87"/>
+            </a:solidFill>
+          </a:ln>
+        </p:spPr>
+        <p:style>
+          <a:lnRef idx="1">
+            <a:schemeClr val="accent1"/>
+          </a:lnRef>
+          <a:fillRef idx="3">
+            <a:schemeClr val="accent1"/>
+          </a:fillRef>
+          <a:effectRef idx="2">
+            <a:schemeClr val="accent1"/>
+          </a:effectRef>
+          <a:fontRef idx="minor">
+            <a:schemeClr val="lt1"/>
+          </a:fontRef>
+        </p:style>
+        <p:txBody>
+          <a:bodyPr rtlCol="0" anchor="ctr"/>
+          <a:lstStyle/>
+          <a:p>
+            <a:pPr algn="ctr"/>
+          </a:p>
+        </p:txBody>
+      </p:sp>
+      <p:sp>
+        <p:nvSpPr>
+          <p:cNvPr id="8" name="TextBox 7"/>
           <p:cNvSpPr txBox="1"/>
           <p:nvPr/>
         </p:nvSpPr>
         <p:spPr>
           <a:xfrm>
-            <a:off x="640080" y="2377440"/>
-            <a:ext cx="10972800" cy="1280160"/>
+            <a:off x="868680" y="2542032"/>
+            <a:ext cx="5029200" cy="457200"/>
           </a:xfrm>
           <a:prstGeom prst="rect">
             <a:avLst/>
@@ -4345,27 +4053,27 @@
           <a:p>
             <a:pPr algn="l"/>
             <a:r>
-              <a:rPr sz="5600" b="1">
+              <a:rPr sz="2000" b="1">
                 <a:solidFill>
                   <a:srgbClr val="FF2D87"/>
                 </a:solidFill>
                 <a:latin typeface="Calibri"/>
               </a:rPr>
-              <a:t>Open. Print. Save as PDF.</a:t>
-            </a:r>
-          </a:p>
-        </p:txBody>
-      </p:sp>
-      <p:sp>
-        <p:nvSpPr>
-          <p:cNvPr id="8" name="TextBox 7"/>
+              <a:t>1. Wrong destination</a:t>
+            </a:r>
+          </a:p>
+        </p:txBody>
+      </p:sp>
+      <p:sp>
+        <p:nvSpPr>
+          <p:cNvPr id="9" name="TextBox 8"/>
           <p:cNvSpPr txBox="1"/>
           <p:nvPr/>
         </p:nvSpPr>
         <p:spPr>
           <a:xfrm>
-            <a:off x="640080" y="4023360"/>
-            <a:ext cx="10972800" cy="2743200"/>
+            <a:off x="868680" y="3154680"/>
+            <a:ext cx="5029200" cy="1005840"/>
           </a:xfrm>
           <a:prstGeom prst="rect">
             <a:avLst/>
@@ -4378,67 +4086,360 @@
           </a:bodyPr>
           <a:lstStyle/>
           <a:p>
-            <a:pPr algn="l">
-              <a:spcAft>
-                <a:spcPts val="800"/>
-              </a:spcAft>
-            </a:pPr>
-            <a:r>
-              <a:rPr sz="2000">
+            <a:pPr algn="l"/>
+            <a:r>
+              <a:rPr sz="1600" b="0">
                 <a:solidFill>
                   <a:srgbClr val="FAFAFA"/>
                 </a:solidFill>
                 <a:latin typeface="Calibri"/>
               </a:rPr>
-              <a:t>• Works on Windows, Mac, Chromebook, iPhone, and Android.</a:t>
-            </a:r>
-          </a:p>
-          <a:p>
-            <a:pPr algn="l">
-              <a:spcAft>
-                <a:spcPts val="800"/>
-              </a:spcAft>
-            </a:pPr>
-            <a:r>
-              <a:rPr sz="2000">
+              <a:t>If your real printer is selected, it'll print on paper. Always switch the destination to Save as PDF.</a:t>
+            </a:r>
+          </a:p>
+        </p:txBody>
+      </p:sp>
+      <p:sp>
+        <p:nvSpPr>
+          <p:cNvPr id="10" name="Rounded Rectangle 9"/>
+          <p:cNvSpPr/>
+          <p:nvPr/>
+        </p:nvSpPr>
+        <p:spPr>
+          <a:xfrm>
+            <a:off x="6355080" y="2377440"/>
+            <a:ext cx="5440680" cy="1874519"/>
+          </a:xfrm>
+          <a:prstGeom prst="roundRect">
+            <a:avLst/>
+          </a:prstGeom>
+          <a:solidFill>
+            <a:srgbClr val="1C1C26"/>
+          </a:solidFill>
+          <a:ln w="19050">
+            <a:solidFill>
+              <a:srgbClr val="FF2D87"/>
+            </a:solidFill>
+          </a:ln>
+        </p:spPr>
+        <p:style>
+          <a:lnRef idx="1">
+            <a:schemeClr val="accent1"/>
+          </a:lnRef>
+          <a:fillRef idx="3">
+            <a:schemeClr val="accent1"/>
+          </a:fillRef>
+          <a:effectRef idx="2">
+            <a:schemeClr val="accent1"/>
+          </a:effectRef>
+          <a:fontRef idx="minor">
+            <a:schemeClr val="lt1"/>
+          </a:fontRef>
+        </p:style>
+        <p:txBody>
+          <a:bodyPr rtlCol="0" anchor="ctr"/>
+          <a:lstStyle/>
+          <a:p>
+            <a:pPr algn="ctr"/>
+          </a:p>
+        </p:txBody>
+      </p:sp>
+      <p:sp>
+        <p:nvSpPr>
+          <p:cNvPr id="11" name="TextBox 10"/>
+          <p:cNvSpPr txBox="1"/>
+          <p:nvPr/>
+        </p:nvSpPr>
+        <p:spPr>
+          <a:xfrm>
+            <a:off x="6583680" y="2542032"/>
+            <a:ext cx="5029200" cy="457200"/>
+          </a:xfrm>
+          <a:prstGeom prst="rect">
+            <a:avLst/>
+          </a:prstGeom>
+          <a:noFill/>
+        </p:spPr>
+        <p:txBody>
+          <a:bodyPr wrap="square">
+            <a:spAutoFit/>
+          </a:bodyPr>
+          <a:lstStyle/>
+          <a:p>
+            <a:pPr algn="l"/>
+            <a:r>
+              <a:rPr sz="2000" b="1">
+                <a:solidFill>
+                  <a:srgbClr val="FF2D87"/>
+                </a:solidFill>
+                <a:latin typeface="Calibri"/>
+              </a:rPr>
+              <a:t>2. Cropped image</a:t>
+            </a:r>
+          </a:p>
+        </p:txBody>
+      </p:sp>
+      <p:sp>
+        <p:nvSpPr>
+          <p:cNvPr id="12" name="TextBox 11"/>
+          <p:cNvSpPr txBox="1"/>
+          <p:nvPr/>
+        </p:nvSpPr>
+        <p:spPr>
+          <a:xfrm>
+            <a:off x="6583680" y="3154680"/>
+            <a:ext cx="5029200" cy="1005840"/>
+          </a:xfrm>
+          <a:prstGeom prst="rect">
+            <a:avLst/>
+          </a:prstGeom>
+          <a:noFill/>
+        </p:spPr>
+        <p:txBody>
+          <a:bodyPr wrap="square">
+            <a:spAutoFit/>
+          </a:bodyPr>
+          <a:lstStyle/>
+          <a:p>
+            <a:pPr algn="l"/>
+            <a:r>
+              <a:rPr sz="1600" b="0">
                 <a:solidFill>
                   <a:srgbClr val="FAFAFA"/>
                 </a:solidFill>
                 <a:latin typeface="Calibri"/>
               </a:rPr>
-              <a:t>• No software to download, no account to make.</a:t>
-            </a:r>
-          </a:p>
-          <a:p>
-            <a:pPr algn="l">
-              <a:spcAft>
-                <a:spcPts val="800"/>
-              </a:spcAft>
-            </a:pPr>
-            <a:r>
-              <a:rPr sz="2000">
+              <a:t>If the photo is cut off, change orientation to Landscape or shrink margins to None.</a:t>
+            </a:r>
+          </a:p>
+        </p:txBody>
+      </p:sp>
+      <p:sp>
+        <p:nvSpPr>
+          <p:cNvPr id="13" name="Rounded Rectangle 12"/>
+          <p:cNvSpPr/>
+          <p:nvPr/>
+        </p:nvSpPr>
+        <p:spPr>
+          <a:xfrm>
+            <a:off x="640080" y="4526280"/>
+            <a:ext cx="5440680" cy="1874519"/>
+          </a:xfrm>
+          <a:prstGeom prst="roundRect">
+            <a:avLst/>
+          </a:prstGeom>
+          <a:solidFill>
+            <a:srgbClr val="1C1C26"/>
+          </a:solidFill>
+          <a:ln w="19050">
+            <a:solidFill>
+              <a:srgbClr val="FF2D87"/>
+            </a:solidFill>
+          </a:ln>
+        </p:spPr>
+        <p:style>
+          <a:lnRef idx="1">
+            <a:schemeClr val="accent1"/>
+          </a:lnRef>
+          <a:fillRef idx="3">
+            <a:schemeClr val="accent1"/>
+          </a:fillRef>
+          <a:effectRef idx="2">
+            <a:schemeClr val="accent1"/>
+          </a:effectRef>
+          <a:fontRef idx="minor">
+            <a:schemeClr val="lt1"/>
+          </a:fontRef>
+        </p:style>
+        <p:txBody>
+          <a:bodyPr rtlCol="0" anchor="ctr"/>
+          <a:lstStyle/>
+          <a:p>
+            <a:pPr algn="ctr"/>
+          </a:p>
+        </p:txBody>
+      </p:sp>
+      <p:sp>
+        <p:nvSpPr>
+          <p:cNvPr id="14" name="TextBox 13"/>
+          <p:cNvSpPr txBox="1"/>
+          <p:nvPr/>
+        </p:nvSpPr>
+        <p:spPr>
+          <a:xfrm>
+            <a:off x="868680" y="4690872"/>
+            <a:ext cx="5029200" cy="457200"/>
+          </a:xfrm>
+          <a:prstGeom prst="rect">
+            <a:avLst/>
+          </a:prstGeom>
+          <a:noFill/>
+        </p:spPr>
+        <p:txBody>
+          <a:bodyPr wrap="square">
+            <a:spAutoFit/>
+          </a:bodyPr>
+          <a:lstStyle/>
+          <a:p>
+            <a:pPr algn="l"/>
+            <a:r>
+              <a:rPr sz="2000" b="1">
+                <a:solidFill>
+                  <a:srgbClr val="FF2D87"/>
+                </a:solidFill>
+                <a:latin typeface="Calibri"/>
+              </a:rPr>
+              <a:t>3. Lost file</a:t>
+            </a:r>
+          </a:p>
+        </p:txBody>
+      </p:sp>
+      <p:sp>
+        <p:nvSpPr>
+          <p:cNvPr id="15" name="TextBox 14"/>
+          <p:cNvSpPr txBox="1"/>
+          <p:nvPr/>
+        </p:nvSpPr>
+        <p:spPr>
+          <a:xfrm>
+            <a:off x="868680" y="5303520"/>
+            <a:ext cx="5029200" cy="1005840"/>
+          </a:xfrm>
+          <a:prstGeom prst="rect">
+            <a:avLst/>
+          </a:prstGeom>
+          <a:noFill/>
+        </p:spPr>
+        <p:txBody>
+          <a:bodyPr wrap="square">
+            <a:spAutoFit/>
+          </a:bodyPr>
+          <a:lstStyle/>
+          <a:p>
+            <a:pPr algn="l"/>
+            <a:r>
+              <a:rPr sz="1600" b="0">
                 <a:solidFill>
                   <a:srgbClr val="FAFAFA"/>
                 </a:solidFill>
                 <a:latin typeface="Calibri"/>
               </a:rPr>
-              <a:t>• Combine multiple images by selecting them all first.</a:t>
-            </a:r>
-          </a:p>
-          <a:p>
-            <a:pPr algn="l">
-              <a:spcAft>
-                <a:spcPts val="800"/>
-              </a:spcAft>
-            </a:pPr>
-            <a:r>
-              <a:rPr sz="2000">
+              <a:t>Note the folder before you click Save. Default is usually Documents or Downloads.</a:t>
+            </a:r>
+          </a:p>
+        </p:txBody>
+      </p:sp>
+      <p:sp>
+        <p:nvSpPr>
+          <p:cNvPr id="16" name="Rounded Rectangle 15"/>
+          <p:cNvSpPr/>
+          <p:nvPr/>
+        </p:nvSpPr>
+        <p:spPr>
+          <a:xfrm>
+            <a:off x="6355080" y="4526280"/>
+            <a:ext cx="5440680" cy="1874519"/>
+          </a:xfrm>
+          <a:prstGeom prst="roundRect">
+            <a:avLst/>
+          </a:prstGeom>
+          <a:solidFill>
+            <a:srgbClr val="1C1C26"/>
+          </a:solidFill>
+          <a:ln w="19050">
+            <a:solidFill>
+              <a:srgbClr val="FF2D87"/>
+            </a:solidFill>
+          </a:ln>
+        </p:spPr>
+        <p:style>
+          <a:lnRef idx="1">
+            <a:schemeClr val="accent1"/>
+          </a:lnRef>
+          <a:fillRef idx="3">
+            <a:schemeClr val="accent1"/>
+          </a:fillRef>
+          <a:effectRef idx="2">
+            <a:schemeClr val="accent1"/>
+          </a:effectRef>
+          <a:fontRef idx="minor">
+            <a:schemeClr val="lt1"/>
+          </a:fontRef>
+        </p:style>
+        <p:txBody>
+          <a:bodyPr rtlCol="0" anchor="ctr"/>
+          <a:lstStyle/>
+          <a:p>
+            <a:pPr algn="ctr"/>
+          </a:p>
+        </p:txBody>
+      </p:sp>
+      <p:sp>
+        <p:nvSpPr>
+          <p:cNvPr id="17" name="TextBox 16"/>
+          <p:cNvSpPr txBox="1"/>
+          <p:nvPr/>
+        </p:nvSpPr>
+        <p:spPr>
+          <a:xfrm>
+            <a:off x="6583680" y="4690872"/>
+            <a:ext cx="5029200" cy="457200"/>
+          </a:xfrm>
+          <a:prstGeom prst="rect">
+            <a:avLst/>
+          </a:prstGeom>
+          <a:noFill/>
+        </p:spPr>
+        <p:txBody>
+          <a:bodyPr wrap="square">
+            <a:spAutoFit/>
+          </a:bodyPr>
+          <a:lstStyle/>
+          <a:p>
+            <a:pPr algn="l"/>
+            <a:r>
+              <a:rPr sz="2000" b="1">
+                <a:solidFill>
+                  <a:srgbClr val="FF2D87"/>
+                </a:solidFill>
+                <a:latin typeface="Calibri"/>
+              </a:rPr>
+              <a:t>Bonus: huge file size</a:t>
+            </a:r>
+          </a:p>
+        </p:txBody>
+      </p:sp>
+      <p:sp>
+        <p:nvSpPr>
+          <p:cNvPr id="18" name="TextBox 17"/>
+          <p:cNvSpPr txBox="1"/>
+          <p:nvPr/>
+        </p:nvSpPr>
+        <p:spPr>
+          <a:xfrm>
+            <a:off x="6583680" y="5303520"/>
+            <a:ext cx="5029200" cy="1005840"/>
+          </a:xfrm>
+          <a:prstGeom prst="rect">
+            <a:avLst/>
+          </a:prstGeom>
+          <a:noFill/>
+        </p:spPr>
+        <p:txBody>
+          <a:bodyPr wrap="square">
+            <a:spAutoFit/>
+          </a:bodyPr>
+          <a:lstStyle/>
+          <a:p>
+            <a:pPr algn="l"/>
+            <a:r>
+              <a:rPr sz="1600" b="0">
                 <a:solidFill>
                   <a:srgbClr val="FAFAFA"/>
                 </a:solidFill>
                 <a:latin typeface="Calibri"/>
               </a:rPr>
-              <a:t>• Name your file something you can find later.</a:t>
+              <a:t>If the PDF is too big to email, lower print quality to Standard or use a smaller paper size.</a:t>
             </a:r>
           </a:p>
         </p:txBody>
@@ -4452,6 +4453,345 @@
 </file>
 
 <file path=ppt/slides/slide12.xml><?xml version="1.0" encoding="utf-8"?>
+<p:sld xmlns:a="http://schemas.openxmlformats.org/drawingml/2006/main" xmlns:p="http://schemas.openxmlformats.org/presentationml/2006/main" xmlns:r="http://schemas.openxmlformats.org/officeDocument/2006/relationships">
+  <p:cSld>
+    <p:spTree>
+      <p:nvGrpSpPr>
+        <p:cNvPr id="1" name=""/>
+        <p:cNvGrpSpPr/>
+        <p:nvPr/>
+      </p:nvGrpSpPr>
+      <p:grpSpPr/>
+      <p:sp>
+        <p:nvSpPr>
+          <p:cNvPr id="2" name="Rectangle 1"/>
+          <p:cNvSpPr/>
+          <p:nvPr/>
+        </p:nvSpPr>
+        <p:spPr>
+          <a:xfrm>
+            <a:off x="0" y="0"/>
+            <a:ext cx="12191695" cy="6858000"/>
+          </a:xfrm>
+          <a:prstGeom prst="rect">
+            <a:avLst/>
+          </a:prstGeom>
+          <a:solidFill>
+            <a:srgbClr val="0F0F14"/>
+          </a:solidFill>
+          <a:ln>
+            <a:noFill/>
+          </a:ln>
+        </p:spPr>
+        <p:style>
+          <a:lnRef idx="1">
+            <a:schemeClr val="accent1"/>
+          </a:lnRef>
+          <a:fillRef idx="3">
+            <a:schemeClr val="accent1"/>
+          </a:fillRef>
+          <a:effectRef idx="2">
+            <a:schemeClr val="accent1"/>
+          </a:effectRef>
+          <a:fontRef idx="minor">
+            <a:schemeClr val="lt1"/>
+          </a:fontRef>
+        </p:style>
+        <p:txBody>
+          <a:bodyPr rtlCol="0" anchor="ctr"/>
+          <a:lstStyle/>
+          <a:p>
+            <a:pPr algn="ctr"/>
+          </a:p>
+        </p:txBody>
+      </p:sp>
+      <p:sp>
+        <p:nvSpPr>
+          <p:cNvPr id="3" name="Rectangle 2"/>
+          <p:cNvSpPr/>
+          <p:nvPr/>
+        </p:nvSpPr>
+        <p:spPr>
+          <a:xfrm>
+            <a:off x="0" y="0"/>
+            <a:ext cx="12191695" cy="164592"/>
+          </a:xfrm>
+          <a:prstGeom prst="rect">
+            <a:avLst/>
+          </a:prstGeom>
+          <a:solidFill>
+            <a:srgbClr val="FF2D87"/>
+          </a:solidFill>
+          <a:ln>
+            <a:noFill/>
+          </a:ln>
+        </p:spPr>
+        <p:style>
+          <a:lnRef idx="1">
+            <a:schemeClr val="accent1"/>
+          </a:lnRef>
+          <a:fillRef idx="3">
+            <a:schemeClr val="accent1"/>
+          </a:fillRef>
+          <a:effectRef idx="2">
+            <a:schemeClr val="accent1"/>
+          </a:effectRef>
+          <a:fontRef idx="minor">
+            <a:schemeClr val="lt1"/>
+          </a:fontRef>
+        </p:style>
+        <p:txBody>
+          <a:bodyPr rtlCol="0" anchor="ctr"/>
+          <a:lstStyle/>
+          <a:p>
+            <a:pPr algn="ctr"/>
+          </a:p>
+        </p:txBody>
+      </p:sp>
+      <p:sp>
+        <p:nvSpPr>
+          <p:cNvPr id="4" name="Rectangle 3"/>
+          <p:cNvSpPr/>
+          <p:nvPr/>
+        </p:nvSpPr>
+        <p:spPr>
+          <a:xfrm>
+            <a:off x="0" y="6766560"/>
+            <a:ext cx="12191695" cy="91440"/>
+          </a:xfrm>
+          <a:prstGeom prst="rect">
+            <a:avLst/>
+          </a:prstGeom>
+          <a:solidFill>
+            <a:srgbClr val="FFD60A"/>
+          </a:solidFill>
+          <a:ln>
+            <a:noFill/>
+          </a:ln>
+        </p:spPr>
+        <p:style>
+          <a:lnRef idx="1">
+            <a:schemeClr val="accent1"/>
+          </a:lnRef>
+          <a:fillRef idx="3">
+            <a:schemeClr val="accent1"/>
+          </a:fillRef>
+          <a:effectRef idx="2">
+            <a:schemeClr val="accent1"/>
+          </a:effectRef>
+          <a:fontRef idx="minor">
+            <a:schemeClr val="lt1"/>
+          </a:fontRef>
+        </p:style>
+        <p:txBody>
+          <a:bodyPr rtlCol="0" anchor="ctr"/>
+          <a:lstStyle/>
+          <a:p>
+            <a:pPr algn="ctr"/>
+          </a:p>
+        </p:txBody>
+      </p:sp>
+      <p:sp>
+        <p:nvSpPr>
+          <p:cNvPr id="5" name="TextBox 4"/>
+          <p:cNvSpPr txBox="1"/>
+          <p:nvPr/>
+        </p:nvSpPr>
+        <p:spPr>
+          <a:xfrm>
+            <a:off x="640080" y="411480"/>
+            <a:ext cx="10972800" cy="411480"/>
+          </a:xfrm>
+          <a:prstGeom prst="rect">
+            <a:avLst/>
+          </a:prstGeom>
+          <a:noFill/>
+        </p:spPr>
+        <p:txBody>
+          <a:bodyPr wrap="square">
+            <a:spAutoFit/>
+          </a:bodyPr>
+          <a:lstStyle/>
+          <a:p>
+            <a:pPr algn="l"/>
+            <a:r>
+              <a:rPr sz="1400" b="1">
+                <a:solidFill>
+                  <a:srgbClr val="FFD60A"/>
+                </a:solidFill>
+                <a:latin typeface="Calibri"/>
+              </a:rPr>
+              <a:t>QUICK RECAP</a:t>
+            </a:r>
+          </a:p>
+        </p:txBody>
+      </p:sp>
+      <p:sp>
+        <p:nvSpPr>
+          <p:cNvPr id="6" name="TextBox 5"/>
+          <p:cNvSpPr txBox="1"/>
+          <p:nvPr/>
+        </p:nvSpPr>
+        <p:spPr>
+          <a:xfrm>
+            <a:off x="640080" y="868680"/>
+            <a:ext cx="10972800" cy="1463040"/>
+          </a:xfrm>
+          <a:prstGeom prst="rect">
+            <a:avLst/>
+          </a:prstGeom>
+          <a:noFill/>
+        </p:spPr>
+        <p:txBody>
+          <a:bodyPr wrap="square">
+            <a:spAutoFit/>
+          </a:bodyPr>
+          <a:lstStyle/>
+          <a:p>
+            <a:pPr algn="l"/>
+            <a:r>
+              <a:rPr sz="4000" b="1">
+                <a:solidFill>
+                  <a:srgbClr val="FAFAFA"/>
+                </a:solidFill>
+                <a:latin typeface="Calibri"/>
+              </a:rPr>
+              <a:t>The whole skill in five words:</a:t>
+            </a:r>
+          </a:p>
+        </p:txBody>
+      </p:sp>
+      <p:sp>
+        <p:nvSpPr>
+          <p:cNvPr id="7" name="TextBox 6"/>
+          <p:cNvSpPr txBox="1"/>
+          <p:nvPr/>
+        </p:nvSpPr>
+        <p:spPr>
+          <a:xfrm>
+            <a:off x="640080" y="2377440"/>
+            <a:ext cx="10972800" cy="1280160"/>
+          </a:xfrm>
+          <a:prstGeom prst="rect">
+            <a:avLst/>
+          </a:prstGeom>
+          <a:noFill/>
+        </p:spPr>
+        <p:txBody>
+          <a:bodyPr wrap="square">
+            <a:spAutoFit/>
+          </a:bodyPr>
+          <a:lstStyle/>
+          <a:p>
+            <a:pPr algn="l"/>
+            <a:r>
+              <a:rPr sz="5600" b="1">
+                <a:solidFill>
+                  <a:srgbClr val="FF2D87"/>
+                </a:solidFill>
+                <a:latin typeface="Calibri"/>
+              </a:rPr>
+              <a:t>Open. Print. Save as PDF.</a:t>
+            </a:r>
+          </a:p>
+        </p:txBody>
+      </p:sp>
+      <p:sp>
+        <p:nvSpPr>
+          <p:cNvPr id="8" name="TextBox 7"/>
+          <p:cNvSpPr txBox="1"/>
+          <p:nvPr/>
+        </p:nvSpPr>
+        <p:spPr>
+          <a:xfrm>
+            <a:off x="640080" y="4023360"/>
+            <a:ext cx="10972800" cy="2743200"/>
+          </a:xfrm>
+          <a:prstGeom prst="rect">
+            <a:avLst/>
+          </a:prstGeom>
+          <a:noFill/>
+        </p:spPr>
+        <p:txBody>
+          <a:bodyPr wrap="square">
+            <a:spAutoFit/>
+          </a:bodyPr>
+          <a:lstStyle/>
+          <a:p>
+            <a:pPr algn="l">
+              <a:spcAft>
+                <a:spcPts val="800"/>
+              </a:spcAft>
+            </a:pPr>
+            <a:r>
+              <a:rPr sz="2000">
+                <a:solidFill>
+                  <a:srgbClr val="FAFAFA"/>
+                </a:solidFill>
+                <a:latin typeface="Calibri"/>
+              </a:rPr>
+              <a:t>• Works on Windows, Mac, Chromebook, iPhone, and Android.</a:t>
+            </a:r>
+          </a:p>
+          <a:p>
+            <a:pPr algn="l">
+              <a:spcAft>
+                <a:spcPts val="800"/>
+              </a:spcAft>
+            </a:pPr>
+            <a:r>
+              <a:rPr sz="2000">
+                <a:solidFill>
+                  <a:srgbClr val="FAFAFA"/>
+                </a:solidFill>
+                <a:latin typeface="Calibri"/>
+              </a:rPr>
+              <a:t>• No software to download, no account to make.</a:t>
+            </a:r>
+          </a:p>
+          <a:p>
+            <a:pPr algn="l">
+              <a:spcAft>
+                <a:spcPts val="800"/>
+              </a:spcAft>
+            </a:pPr>
+            <a:r>
+              <a:rPr sz="2000">
+                <a:solidFill>
+                  <a:srgbClr val="FAFAFA"/>
+                </a:solidFill>
+                <a:latin typeface="Calibri"/>
+              </a:rPr>
+              <a:t>• Combine multiple images by selecting them all first.</a:t>
+            </a:r>
+          </a:p>
+          <a:p>
+            <a:pPr algn="l">
+              <a:spcAft>
+                <a:spcPts val="800"/>
+              </a:spcAft>
+            </a:pPr>
+            <a:r>
+              <a:rPr sz="2000">
+                <a:solidFill>
+                  <a:srgbClr val="FAFAFA"/>
+                </a:solidFill>
+                <a:latin typeface="Calibri"/>
+              </a:rPr>
+              <a:t>• Name your file something you can find later.</a:t>
+            </a:r>
+          </a:p>
+        </p:txBody>
+      </p:sp>
+    </p:spTree>
+  </p:cSld>
+  <p:clrMapOvr>
+    <a:masterClrMapping/>
+  </p:clrMapOvr>
+</p:sld>
+</file>
+
+<file path=ppt/slides/slide13.xml><?xml version="1.0" encoding="utf-8"?>
 <p:sld xmlns:a="http://schemas.openxmlformats.org/drawingml/2006/main" xmlns:p="http://schemas.openxmlformats.org/presentationml/2006/main" xmlns:r="http://schemas.openxmlformats.org/officeDocument/2006/relationships">
   <p:cSld>
     <p:spTree>
@@ -7847,7 +8187,7 @@
                 </a:solidFill>
                 <a:latin typeface="Calibri"/>
               </a:rPr>
-              <a:t>YOUR TURN</a:t>
+              <a:t>SHORTCUT</a:t>
             </a:r>
           </a:p>
         </p:txBody>
@@ -7876,13 +8216,13 @@
           <a:p>
             <a:pPr algn="l"/>
             <a:r>
-              <a:rPr sz="4400" b="1">
+              <a:rPr sz="3400" b="1">
                 <a:solidFill>
                   <a:srgbClr val="FAFAFA"/>
                 </a:solidFill>
                 <a:latin typeface="Calibri"/>
               </a:rPr>
-              <a:t>Try it with me — 60 seconds.</a:t>
+              <a:t>Skip the Print dialog with Export → PDF</a:t>
             </a:r>
           </a:p>
         </p:txBody>
@@ -7895,8 +8235,8 @@
         </p:nvSpPr>
         <p:spPr>
           <a:xfrm>
-            <a:off x="640080" y="2377440"/>
-            <a:ext cx="10972800" cy="4023360"/>
+            <a:off x="640080" y="1828800"/>
+            <a:ext cx="10972800" cy="640080"/>
           </a:xfrm>
           <a:prstGeom prst="rect">
             <a:avLst/>
@@ -7909,81 +8249,74 @@
           </a:bodyPr>
           <a:lstStyle/>
           <a:p>
-            <a:pPr algn="l">
-              <a:spcAft>
-                <a:spcPts val="800"/>
-              </a:spcAft>
-            </a:pPr>
-            <a:r>
-              <a:rPr sz="2200">
+            <a:pPr algn="l"/>
+            <a:r>
+              <a:rPr sz="2000" b="0">
                 <a:solidFill>
                   <a:srgbClr val="FAFAFA"/>
                 </a:solidFill>
                 <a:latin typeface="Calibri"/>
               </a:rPr>
-              <a:t>• Pick any photo on your device.</a:t>
-            </a:r>
-          </a:p>
-          <a:p>
-            <a:pPr algn="l">
-              <a:spcAft>
-                <a:spcPts val="800"/>
-              </a:spcAft>
-            </a:pPr>
-            <a:r>
-              <a:rPr sz="2200">
-                <a:solidFill>
-                  <a:srgbClr val="FAFAFA"/>
-                </a:solidFill>
-                <a:latin typeface="Calibri"/>
-              </a:rPr>
-              <a:t>• Open it. Hit Print.</a:t>
-            </a:r>
-          </a:p>
-          <a:p>
-            <a:pPr algn="l">
-              <a:spcAft>
-                <a:spcPts val="800"/>
-              </a:spcAft>
-            </a:pPr>
-            <a:r>
-              <a:rPr sz="2200">
-                <a:solidFill>
-                  <a:srgbClr val="FAFAFA"/>
-                </a:solidFill>
-                <a:latin typeface="Calibri"/>
-              </a:rPr>
-              <a:t>• Choose "Save as PDF."</a:t>
-            </a:r>
-          </a:p>
-          <a:p>
-            <a:pPr algn="l">
-              <a:spcAft>
-                <a:spcPts val="800"/>
-              </a:spcAft>
-            </a:pPr>
-            <a:r>
-              <a:rPr sz="2200">
-                <a:solidFill>
-                  <a:srgbClr val="FAFAFA"/>
-                </a:solidFill>
-                <a:latin typeface="Calibri"/>
-              </a:rPr>
-              <a:t>• Save it to your Desktop as test.pdf.</a:t>
-            </a:r>
-          </a:p>
-        </p:txBody>
-      </p:sp>
-      <p:sp>
-        <p:nvSpPr>
-          <p:cNvPr id="8" name="TextBox 7"/>
+              <a:t>Some apps offer a one-step PDF export. Always check the File menu first.</a:t>
+            </a:r>
+          </a:p>
+        </p:txBody>
+      </p:sp>
+      <p:sp>
+        <p:nvSpPr>
+          <p:cNvPr id="8" name="Rounded Rectangle 7"/>
+          <p:cNvSpPr/>
+          <p:nvPr/>
+        </p:nvSpPr>
+        <p:spPr>
+          <a:xfrm>
+            <a:off x="640080" y="2651760"/>
+            <a:ext cx="5440680" cy="1691640"/>
+          </a:xfrm>
+          <a:prstGeom prst="roundRect">
+            <a:avLst/>
+          </a:prstGeom>
+          <a:solidFill>
+            <a:srgbClr val="1C1C26"/>
+          </a:solidFill>
+          <a:ln w="19050">
+            <a:solidFill>
+              <a:srgbClr val="FFD60A"/>
+            </a:solidFill>
+          </a:ln>
+        </p:spPr>
+        <p:style>
+          <a:lnRef idx="1">
+            <a:schemeClr val="accent1"/>
+          </a:lnRef>
+          <a:fillRef idx="3">
+            <a:schemeClr val="accent1"/>
+          </a:fillRef>
+          <a:effectRef idx="2">
+            <a:schemeClr val="accent1"/>
+          </a:effectRef>
+          <a:fontRef idx="minor">
+            <a:schemeClr val="lt1"/>
+          </a:fontRef>
+        </p:style>
+        <p:txBody>
+          <a:bodyPr rtlCol="0" anchor="ctr"/>
+          <a:lstStyle/>
+          <a:p>
+            <a:pPr algn="ctr"/>
+          </a:p>
+        </p:txBody>
+      </p:sp>
+      <p:sp>
+        <p:nvSpPr>
+          <p:cNvPr id="9" name="TextBox 8"/>
           <p:cNvSpPr txBox="1"/>
           <p:nvPr/>
         </p:nvSpPr>
         <p:spPr>
           <a:xfrm>
-            <a:off x="640080" y="5852160"/>
-            <a:ext cx="10972800" cy="548640"/>
+            <a:off x="868680" y="2816352"/>
+            <a:ext cx="5029200" cy="457200"/>
           </a:xfrm>
           <a:prstGeom prst="rect">
             <a:avLst/>
@@ -7998,13 +8331,428 @@
           <a:p>
             <a:pPr algn="l"/>
             <a:r>
+              <a:rPr sz="2000" b="1">
+                <a:solidFill>
+                  <a:srgbClr val="FFD60A"/>
+                </a:solidFill>
+                <a:latin typeface="Calibri"/>
+              </a:rPr>
+              <a:t>Word · PowerPoint</a:t>
+            </a:r>
+          </a:p>
+        </p:txBody>
+      </p:sp>
+      <p:sp>
+        <p:nvSpPr>
+          <p:cNvPr id="10" name="TextBox 9"/>
+          <p:cNvSpPr txBox="1"/>
+          <p:nvPr/>
+        </p:nvSpPr>
+        <p:spPr>
+          <a:xfrm>
+            <a:off x="868680" y="3364991"/>
+            <a:ext cx="5029200" cy="914400"/>
+          </a:xfrm>
+          <a:prstGeom prst="rect">
+            <a:avLst/>
+          </a:prstGeom>
+          <a:noFill/>
+        </p:spPr>
+        <p:txBody>
+          <a:bodyPr wrap="square">
+            <a:spAutoFit/>
+          </a:bodyPr>
+          <a:lstStyle/>
+          <a:p>
+            <a:pPr algn="l"/>
+            <a:r>
               <a:rPr sz="1800" b="0">
                 <a:solidFill>
                   <a:srgbClr val="FAFAFA"/>
                 </a:solidFill>
                 <a:latin typeface="Calibri"/>
               </a:rPr>
-              <a:t>Raise your hand if you get stuck — I'll come help.</a:t>
+              <a:t>File  →  Export  →  Create PDF/XPS Document</a:t>
+            </a:r>
+          </a:p>
+        </p:txBody>
+      </p:sp>
+      <p:sp>
+        <p:nvSpPr>
+          <p:cNvPr id="11" name="Rounded Rectangle 10"/>
+          <p:cNvSpPr/>
+          <p:nvPr/>
+        </p:nvSpPr>
+        <p:spPr>
+          <a:xfrm>
+            <a:off x="6355080" y="2651760"/>
+            <a:ext cx="5440680" cy="1691640"/>
+          </a:xfrm>
+          <a:prstGeom prst="roundRect">
+            <a:avLst/>
+          </a:prstGeom>
+          <a:solidFill>
+            <a:srgbClr val="1C1C26"/>
+          </a:solidFill>
+          <a:ln w="19050">
+            <a:solidFill>
+              <a:srgbClr val="FFD60A"/>
+            </a:solidFill>
+          </a:ln>
+        </p:spPr>
+        <p:style>
+          <a:lnRef idx="1">
+            <a:schemeClr val="accent1"/>
+          </a:lnRef>
+          <a:fillRef idx="3">
+            <a:schemeClr val="accent1"/>
+          </a:fillRef>
+          <a:effectRef idx="2">
+            <a:schemeClr val="accent1"/>
+          </a:effectRef>
+          <a:fontRef idx="minor">
+            <a:schemeClr val="lt1"/>
+          </a:fontRef>
+        </p:style>
+        <p:txBody>
+          <a:bodyPr rtlCol="0" anchor="ctr"/>
+          <a:lstStyle/>
+          <a:p>
+            <a:pPr algn="ctr"/>
+          </a:p>
+        </p:txBody>
+      </p:sp>
+      <p:sp>
+        <p:nvSpPr>
+          <p:cNvPr id="12" name="TextBox 11"/>
+          <p:cNvSpPr txBox="1"/>
+          <p:nvPr/>
+        </p:nvSpPr>
+        <p:spPr>
+          <a:xfrm>
+            <a:off x="6583680" y="2816352"/>
+            <a:ext cx="5029200" cy="457200"/>
+          </a:xfrm>
+          <a:prstGeom prst="rect">
+            <a:avLst/>
+          </a:prstGeom>
+          <a:noFill/>
+        </p:spPr>
+        <p:txBody>
+          <a:bodyPr wrap="square">
+            <a:spAutoFit/>
+          </a:bodyPr>
+          <a:lstStyle/>
+          <a:p>
+            <a:pPr algn="l"/>
+            <a:r>
+              <a:rPr sz="2000" b="1">
+                <a:solidFill>
+                  <a:srgbClr val="FFD60A"/>
+                </a:solidFill>
+                <a:latin typeface="Calibri"/>
+              </a:rPr>
+              <a:t>Pages · Numbers · Keynote</a:t>
+            </a:r>
+          </a:p>
+        </p:txBody>
+      </p:sp>
+      <p:sp>
+        <p:nvSpPr>
+          <p:cNvPr id="13" name="TextBox 12"/>
+          <p:cNvSpPr txBox="1"/>
+          <p:nvPr/>
+        </p:nvSpPr>
+        <p:spPr>
+          <a:xfrm>
+            <a:off x="6583680" y="3364991"/>
+            <a:ext cx="5029200" cy="914400"/>
+          </a:xfrm>
+          <a:prstGeom prst="rect">
+            <a:avLst/>
+          </a:prstGeom>
+          <a:noFill/>
+        </p:spPr>
+        <p:txBody>
+          <a:bodyPr wrap="square">
+            <a:spAutoFit/>
+          </a:bodyPr>
+          <a:lstStyle/>
+          <a:p>
+            <a:pPr algn="l"/>
+            <a:r>
+              <a:rPr sz="1800" b="0">
+                <a:solidFill>
+                  <a:srgbClr val="FAFAFA"/>
+                </a:solidFill>
+                <a:latin typeface="Calibri"/>
+              </a:rPr>
+              <a:t>File  →  Export To  →  PDF…</a:t>
+            </a:r>
+          </a:p>
+        </p:txBody>
+      </p:sp>
+      <p:sp>
+        <p:nvSpPr>
+          <p:cNvPr id="14" name="Rounded Rectangle 13"/>
+          <p:cNvSpPr/>
+          <p:nvPr/>
+        </p:nvSpPr>
+        <p:spPr>
+          <a:xfrm>
+            <a:off x="640080" y="4572000"/>
+            <a:ext cx="5440680" cy="1691640"/>
+          </a:xfrm>
+          <a:prstGeom prst="roundRect">
+            <a:avLst/>
+          </a:prstGeom>
+          <a:solidFill>
+            <a:srgbClr val="1C1C26"/>
+          </a:solidFill>
+          <a:ln w="19050">
+            <a:solidFill>
+              <a:srgbClr val="FFD60A"/>
+            </a:solidFill>
+          </a:ln>
+        </p:spPr>
+        <p:style>
+          <a:lnRef idx="1">
+            <a:schemeClr val="accent1"/>
+          </a:lnRef>
+          <a:fillRef idx="3">
+            <a:schemeClr val="accent1"/>
+          </a:fillRef>
+          <a:effectRef idx="2">
+            <a:schemeClr val="accent1"/>
+          </a:effectRef>
+          <a:fontRef idx="minor">
+            <a:schemeClr val="lt1"/>
+          </a:fontRef>
+        </p:style>
+        <p:txBody>
+          <a:bodyPr rtlCol="0" anchor="ctr"/>
+          <a:lstStyle/>
+          <a:p>
+            <a:pPr algn="ctr"/>
+          </a:p>
+        </p:txBody>
+      </p:sp>
+      <p:sp>
+        <p:nvSpPr>
+          <p:cNvPr id="15" name="TextBox 14"/>
+          <p:cNvSpPr txBox="1"/>
+          <p:nvPr/>
+        </p:nvSpPr>
+        <p:spPr>
+          <a:xfrm>
+            <a:off x="868680" y="4736592"/>
+            <a:ext cx="5029200" cy="457200"/>
+          </a:xfrm>
+          <a:prstGeom prst="rect">
+            <a:avLst/>
+          </a:prstGeom>
+          <a:noFill/>
+        </p:spPr>
+        <p:txBody>
+          <a:bodyPr wrap="square">
+            <a:spAutoFit/>
+          </a:bodyPr>
+          <a:lstStyle/>
+          <a:p>
+            <a:pPr algn="l"/>
+            <a:r>
+              <a:rPr sz="2000" b="1">
+                <a:solidFill>
+                  <a:srgbClr val="FFD60A"/>
+                </a:solidFill>
+                <a:latin typeface="Calibri"/>
+              </a:rPr>
+              <a:t>Photos (Mac)</a:t>
+            </a:r>
+          </a:p>
+        </p:txBody>
+      </p:sp>
+      <p:sp>
+        <p:nvSpPr>
+          <p:cNvPr id="16" name="TextBox 15"/>
+          <p:cNvSpPr txBox="1"/>
+          <p:nvPr/>
+        </p:nvSpPr>
+        <p:spPr>
+          <a:xfrm>
+            <a:off x="868680" y="5285232"/>
+            <a:ext cx="5029200" cy="914400"/>
+          </a:xfrm>
+          <a:prstGeom prst="rect">
+            <a:avLst/>
+          </a:prstGeom>
+          <a:noFill/>
+        </p:spPr>
+        <p:txBody>
+          <a:bodyPr wrap="square">
+            <a:spAutoFit/>
+          </a:bodyPr>
+          <a:lstStyle/>
+          <a:p>
+            <a:pPr algn="l"/>
+            <a:r>
+              <a:rPr sz="1800" b="0">
+                <a:solidFill>
+                  <a:srgbClr val="FAFAFA"/>
+                </a:solidFill>
+                <a:latin typeface="Calibri"/>
+              </a:rPr>
+              <a:t>File  →  Export  →  Save PDF to…</a:t>
+            </a:r>
+          </a:p>
+        </p:txBody>
+      </p:sp>
+      <p:sp>
+        <p:nvSpPr>
+          <p:cNvPr id="17" name="Rounded Rectangle 16"/>
+          <p:cNvSpPr/>
+          <p:nvPr/>
+        </p:nvSpPr>
+        <p:spPr>
+          <a:xfrm>
+            <a:off x="6355080" y="4572000"/>
+            <a:ext cx="5440680" cy="1691640"/>
+          </a:xfrm>
+          <a:prstGeom prst="roundRect">
+            <a:avLst/>
+          </a:prstGeom>
+          <a:solidFill>
+            <a:srgbClr val="1C1C26"/>
+          </a:solidFill>
+          <a:ln w="19050">
+            <a:solidFill>
+              <a:srgbClr val="FFD60A"/>
+            </a:solidFill>
+          </a:ln>
+        </p:spPr>
+        <p:style>
+          <a:lnRef idx="1">
+            <a:schemeClr val="accent1"/>
+          </a:lnRef>
+          <a:fillRef idx="3">
+            <a:schemeClr val="accent1"/>
+          </a:fillRef>
+          <a:effectRef idx="2">
+            <a:schemeClr val="accent1"/>
+          </a:effectRef>
+          <a:fontRef idx="minor">
+            <a:schemeClr val="lt1"/>
+          </a:fontRef>
+        </p:style>
+        <p:txBody>
+          <a:bodyPr rtlCol="0" anchor="ctr"/>
+          <a:lstStyle/>
+          <a:p>
+            <a:pPr algn="ctr"/>
+          </a:p>
+        </p:txBody>
+      </p:sp>
+      <p:sp>
+        <p:nvSpPr>
+          <p:cNvPr id="18" name="TextBox 17"/>
+          <p:cNvSpPr txBox="1"/>
+          <p:nvPr/>
+        </p:nvSpPr>
+        <p:spPr>
+          <a:xfrm>
+            <a:off x="6583680" y="4736592"/>
+            <a:ext cx="5029200" cy="457200"/>
+          </a:xfrm>
+          <a:prstGeom prst="rect">
+            <a:avLst/>
+          </a:prstGeom>
+          <a:noFill/>
+        </p:spPr>
+        <p:txBody>
+          <a:bodyPr wrap="square">
+            <a:spAutoFit/>
+          </a:bodyPr>
+          <a:lstStyle/>
+          <a:p>
+            <a:pPr algn="l"/>
+            <a:r>
+              <a:rPr sz="2000" b="1">
+                <a:solidFill>
+                  <a:srgbClr val="FFD60A"/>
+                </a:solidFill>
+                <a:latin typeface="Calibri"/>
+              </a:rPr>
+              <a:t>Google Docs · Slides · Sheets</a:t>
+            </a:r>
+          </a:p>
+        </p:txBody>
+      </p:sp>
+      <p:sp>
+        <p:nvSpPr>
+          <p:cNvPr id="19" name="TextBox 18"/>
+          <p:cNvSpPr txBox="1"/>
+          <p:nvPr/>
+        </p:nvSpPr>
+        <p:spPr>
+          <a:xfrm>
+            <a:off x="6583680" y="5285232"/>
+            <a:ext cx="5029200" cy="914400"/>
+          </a:xfrm>
+          <a:prstGeom prst="rect">
+            <a:avLst/>
+          </a:prstGeom>
+          <a:noFill/>
+        </p:spPr>
+        <p:txBody>
+          <a:bodyPr wrap="square">
+            <a:spAutoFit/>
+          </a:bodyPr>
+          <a:lstStyle/>
+          <a:p>
+            <a:pPr algn="l"/>
+            <a:r>
+              <a:rPr sz="1800" b="0">
+                <a:solidFill>
+                  <a:srgbClr val="FAFAFA"/>
+                </a:solidFill>
+                <a:latin typeface="Calibri"/>
+              </a:rPr>
+              <a:t>File  →  Download  →  PDF Document (.pdf)</a:t>
+            </a:r>
+          </a:p>
+        </p:txBody>
+      </p:sp>
+      <p:sp>
+        <p:nvSpPr>
+          <p:cNvPr id="20" name="TextBox 19"/>
+          <p:cNvSpPr txBox="1"/>
+          <p:nvPr/>
+        </p:nvSpPr>
+        <p:spPr>
+          <a:xfrm>
+            <a:off x="640080" y="6446520"/>
+            <a:ext cx="10972800" cy="457200"/>
+          </a:xfrm>
+          <a:prstGeom prst="rect">
+            <a:avLst/>
+          </a:prstGeom>
+          <a:noFill/>
+        </p:spPr>
+        <p:txBody>
+          <a:bodyPr wrap="square">
+            <a:spAutoFit/>
+          </a:bodyPr>
+          <a:lstStyle/>
+          <a:p>
+            <a:pPr algn="l"/>
+            <a:r>
+              <a:rPr sz="1400" b="1">
+                <a:solidFill>
+                  <a:srgbClr val="FFD60A"/>
+                </a:solidFill>
+                <a:latin typeface="Calibri"/>
+              </a:rPr>
+              <a:t>If "Export" isn't there, fall back to the Print method we just learned.</a:t>
             </a:r>
           </a:p>
         </p:txBody>

</xml_diff>

<commit_message>
Add interactive sandbox + 'Now you try' slide
- sandbox.html: hands-on practice page where students drop in images
  and trigger the real Print dialog. Drag-drop, file picker, gallery,
  remove/clear, custom title, print stylesheet (one image per page).
- build_qr.py: generates QR code linking to the hosted sandbox URL.
- Slide 10 redesigned: three difficulty tiers (Easy/Medium/Bonus) +
  scannable QR code so the audience can open the sandbox in one tap.
- Sandbox is mobile-friendly so students can practice on their phones.
</commit_message>
<xml_diff>
--- a/Save-Images-as-PDF-Using-Print.pptx
+++ b/Save-Images-as-PDF-Using-Print.pptx
@@ -3605,7 +3605,7 @@
                 </a:solidFill>
                 <a:latin typeface="Calibri"/>
               </a:rPr>
-              <a:t>YOUR TURN</a:t>
+              <a:t>NOW YOU TRY · INTERACTIVE SANDBOX</a:t>
             </a:r>
           </a:p>
         </p:txBody>
@@ -3634,13 +3634,13 @@
           <a:p>
             <a:pPr algn="l"/>
             <a:r>
-              <a:rPr sz="4400" b="1">
+              <a:rPr sz="3200" b="1">
                 <a:solidFill>
                   <a:srgbClr val="FAFAFA"/>
                 </a:solidFill>
                 <a:latin typeface="Calibri"/>
               </a:rPr>
-              <a:t>Try it with me — 60 seconds.</a:t>
+              <a:t>Practice on a real page, live in your browser.</a:t>
             </a:r>
           </a:p>
         </p:txBody>
@@ -3653,8 +3653,8 @@
         </p:nvSpPr>
         <p:spPr>
           <a:xfrm>
-            <a:off x="640080" y="2377440"/>
-            <a:ext cx="10972800" cy="4023360"/>
+            <a:off x="640080" y="1828800"/>
+            <a:ext cx="7589520" cy="640080"/>
           </a:xfrm>
           <a:prstGeom prst="rect">
             <a:avLst/>
@@ -3667,81 +3667,74 @@
           </a:bodyPr>
           <a:lstStyle/>
           <a:p>
-            <a:pPr algn="l">
-              <a:spcAft>
-                <a:spcPts val="800"/>
-              </a:spcAft>
-            </a:pPr>
-            <a:r>
-              <a:rPr sz="2200">
+            <a:pPr algn="l"/>
+            <a:r>
+              <a:rPr sz="1800" b="0">
                 <a:solidFill>
                   <a:srgbClr val="FAFAFA"/>
                 </a:solidFill>
                 <a:latin typeface="Calibri"/>
               </a:rPr>
-              <a:t>• Pick any photo on your device.</a:t>
-            </a:r>
-          </a:p>
-          <a:p>
-            <a:pPr algn="l">
-              <a:spcAft>
-                <a:spcPts val="800"/>
-              </a:spcAft>
-            </a:pPr>
-            <a:r>
-              <a:rPr sz="2200">
-                <a:solidFill>
-                  <a:srgbClr val="FAFAFA"/>
-                </a:solidFill>
-                <a:latin typeface="Calibri"/>
-              </a:rPr>
-              <a:t>• Open it. Hit Print.</a:t>
-            </a:r>
-          </a:p>
-          <a:p>
-            <a:pPr algn="l">
-              <a:spcAft>
-                <a:spcPts val="800"/>
-              </a:spcAft>
-            </a:pPr>
-            <a:r>
-              <a:rPr sz="2200">
-                <a:solidFill>
-                  <a:srgbClr val="FAFAFA"/>
-                </a:solidFill>
-                <a:latin typeface="Calibri"/>
-              </a:rPr>
-              <a:t>• Choose "Save as PDF."</a:t>
-            </a:r>
-          </a:p>
-          <a:p>
-            <a:pPr algn="l">
-              <a:spcAft>
-                <a:spcPts val="800"/>
-              </a:spcAft>
-            </a:pPr>
-            <a:r>
-              <a:rPr sz="2200">
-                <a:solidFill>
-                  <a:srgbClr val="FAFAFA"/>
-                </a:solidFill>
-                <a:latin typeface="Calibri"/>
-              </a:rPr>
-              <a:t>• Save it to your Desktop as test.pdf.</a:t>
-            </a:r>
-          </a:p>
-        </p:txBody>
-      </p:sp>
-      <p:sp>
-        <p:nvSpPr>
-          <p:cNvPr id="8" name="TextBox 7"/>
+              <a:t>Scan the QR code or open the link below. Drop in any photos, then tap "Save as PDF."</a:t>
+            </a:r>
+          </a:p>
+        </p:txBody>
+      </p:sp>
+      <p:sp>
+        <p:nvSpPr>
+          <p:cNvPr id="8" name="Rounded Rectangle 7"/>
+          <p:cNvSpPr/>
+          <p:nvPr/>
+        </p:nvSpPr>
+        <p:spPr>
+          <a:xfrm>
+            <a:off x="640080" y="2788920"/>
+            <a:ext cx="7589520" cy="777240"/>
+          </a:xfrm>
+          <a:prstGeom prst="roundRect">
+            <a:avLst/>
+          </a:prstGeom>
+          <a:solidFill>
+            <a:srgbClr val="1C1C26"/>
+          </a:solidFill>
+          <a:ln w="19050">
+            <a:solidFill>
+              <a:srgbClr val="FF2D87"/>
+            </a:solidFill>
+          </a:ln>
+        </p:spPr>
+        <p:style>
+          <a:lnRef idx="1">
+            <a:schemeClr val="accent1"/>
+          </a:lnRef>
+          <a:fillRef idx="3">
+            <a:schemeClr val="accent1"/>
+          </a:fillRef>
+          <a:effectRef idx="2">
+            <a:schemeClr val="accent1"/>
+          </a:effectRef>
+          <a:fontRef idx="minor">
+            <a:schemeClr val="lt1"/>
+          </a:fontRef>
+        </p:style>
+        <p:txBody>
+          <a:bodyPr rtlCol="0" anchor="ctr"/>
+          <a:lstStyle/>
+          <a:p>
+            <a:pPr algn="ctr"/>
+          </a:p>
+        </p:txBody>
+      </p:sp>
+      <p:sp>
+        <p:nvSpPr>
+          <p:cNvPr id="9" name="TextBox 8"/>
           <p:cNvSpPr txBox="1"/>
           <p:nvPr/>
         </p:nvSpPr>
         <p:spPr>
           <a:xfrm>
-            <a:off x="640080" y="5852160"/>
-            <a:ext cx="10972800" cy="548640"/>
+            <a:off x="868680" y="2953512"/>
+            <a:ext cx="1463040" cy="502920"/>
           </a:xfrm>
           <a:prstGeom prst="rect">
             <a:avLst/>
@@ -3756,13 +3749,407 @@
           <a:p>
             <a:pPr algn="l"/>
             <a:r>
-              <a:rPr sz="1800" b="0">
+              <a:rPr sz="1800" b="1">
+                <a:solidFill>
+                  <a:srgbClr val="FFD60A"/>
+                </a:solidFill>
+                <a:latin typeface="Calibri"/>
+              </a:rPr>
+              <a:t>EASY</a:t>
+            </a:r>
+          </a:p>
+        </p:txBody>
+      </p:sp>
+      <p:sp>
+        <p:nvSpPr>
+          <p:cNvPr id="10" name="TextBox 9"/>
+          <p:cNvSpPr txBox="1"/>
+          <p:nvPr/>
+        </p:nvSpPr>
+        <p:spPr>
+          <a:xfrm>
+            <a:off x="2286000" y="2953512"/>
+            <a:ext cx="5852160" cy="502920"/>
+          </a:xfrm>
+          <a:prstGeom prst="rect">
+            <a:avLst/>
+          </a:prstGeom>
+          <a:noFill/>
+        </p:spPr>
+        <p:txBody>
+          <a:bodyPr wrap="square">
+            <a:spAutoFit/>
+          </a:bodyPr>
+          <a:lstStyle/>
+          <a:p>
+            <a:pPr algn="l"/>
+            <a:r>
+              <a:rPr sz="1700" b="0">
                 <a:solidFill>
                   <a:srgbClr val="FAFAFA"/>
                 </a:solidFill>
                 <a:latin typeface="Calibri"/>
               </a:rPr>
-              <a:t>Raise your hand if you get stuck — I'll come help.</a:t>
+              <a:t>Drop in 1 photo. Save it as 'first.pdf'.</a:t>
+            </a:r>
+          </a:p>
+        </p:txBody>
+      </p:sp>
+      <p:sp>
+        <p:nvSpPr>
+          <p:cNvPr id="11" name="Rounded Rectangle 10"/>
+          <p:cNvSpPr/>
+          <p:nvPr/>
+        </p:nvSpPr>
+        <p:spPr>
+          <a:xfrm>
+            <a:off x="640080" y="3657600"/>
+            <a:ext cx="7589520" cy="777240"/>
+          </a:xfrm>
+          <a:prstGeom prst="roundRect">
+            <a:avLst/>
+          </a:prstGeom>
+          <a:solidFill>
+            <a:srgbClr val="1C1C26"/>
+          </a:solidFill>
+          <a:ln w="19050">
+            <a:solidFill>
+              <a:srgbClr val="FF2D87"/>
+            </a:solidFill>
+          </a:ln>
+        </p:spPr>
+        <p:style>
+          <a:lnRef idx="1">
+            <a:schemeClr val="accent1"/>
+          </a:lnRef>
+          <a:fillRef idx="3">
+            <a:schemeClr val="accent1"/>
+          </a:fillRef>
+          <a:effectRef idx="2">
+            <a:schemeClr val="accent1"/>
+          </a:effectRef>
+          <a:fontRef idx="minor">
+            <a:schemeClr val="lt1"/>
+          </a:fontRef>
+        </p:style>
+        <p:txBody>
+          <a:bodyPr rtlCol="0" anchor="ctr"/>
+          <a:lstStyle/>
+          <a:p>
+            <a:pPr algn="ctr"/>
+          </a:p>
+        </p:txBody>
+      </p:sp>
+      <p:sp>
+        <p:nvSpPr>
+          <p:cNvPr id="12" name="TextBox 11"/>
+          <p:cNvSpPr txBox="1"/>
+          <p:nvPr/>
+        </p:nvSpPr>
+        <p:spPr>
+          <a:xfrm>
+            <a:off x="868680" y="3822191"/>
+            <a:ext cx="1463040" cy="502920"/>
+          </a:xfrm>
+          <a:prstGeom prst="rect">
+            <a:avLst/>
+          </a:prstGeom>
+          <a:noFill/>
+        </p:spPr>
+        <p:txBody>
+          <a:bodyPr wrap="square">
+            <a:spAutoFit/>
+          </a:bodyPr>
+          <a:lstStyle/>
+          <a:p>
+            <a:pPr algn="l"/>
+            <a:r>
+              <a:rPr sz="1800" b="1">
+                <a:solidFill>
+                  <a:srgbClr val="FFD60A"/>
+                </a:solidFill>
+                <a:latin typeface="Calibri"/>
+              </a:rPr>
+              <a:t>MEDIUM</a:t>
+            </a:r>
+          </a:p>
+        </p:txBody>
+      </p:sp>
+      <p:sp>
+        <p:nvSpPr>
+          <p:cNvPr id="13" name="TextBox 12"/>
+          <p:cNvSpPr txBox="1"/>
+          <p:nvPr/>
+        </p:nvSpPr>
+        <p:spPr>
+          <a:xfrm>
+            <a:off x="2286000" y="3822191"/>
+            <a:ext cx="5852160" cy="502920"/>
+          </a:xfrm>
+          <a:prstGeom prst="rect">
+            <a:avLst/>
+          </a:prstGeom>
+          <a:noFill/>
+        </p:spPr>
+        <p:txBody>
+          <a:bodyPr wrap="square">
+            <a:spAutoFit/>
+          </a:bodyPr>
+          <a:lstStyle/>
+          <a:p>
+            <a:pPr algn="l"/>
+            <a:r>
+              <a:rPr sz="1700" b="0">
+                <a:solidFill>
+                  <a:srgbClr val="FAFAFA"/>
+                </a:solidFill>
+                <a:latin typeface="Calibri"/>
+              </a:rPr>
+              <a:t>Drop in 3 photos. Save them as one combined PDF.</a:t>
+            </a:r>
+          </a:p>
+        </p:txBody>
+      </p:sp>
+      <p:sp>
+        <p:nvSpPr>
+          <p:cNvPr id="14" name="Rounded Rectangle 13"/>
+          <p:cNvSpPr/>
+          <p:nvPr/>
+        </p:nvSpPr>
+        <p:spPr>
+          <a:xfrm>
+            <a:off x="640080" y="4526279"/>
+            <a:ext cx="7589520" cy="777240"/>
+          </a:xfrm>
+          <a:prstGeom prst="roundRect">
+            <a:avLst/>
+          </a:prstGeom>
+          <a:solidFill>
+            <a:srgbClr val="1C1C26"/>
+          </a:solidFill>
+          <a:ln w="19050">
+            <a:solidFill>
+              <a:srgbClr val="FF2D87"/>
+            </a:solidFill>
+          </a:ln>
+        </p:spPr>
+        <p:style>
+          <a:lnRef idx="1">
+            <a:schemeClr val="accent1"/>
+          </a:lnRef>
+          <a:fillRef idx="3">
+            <a:schemeClr val="accent1"/>
+          </a:fillRef>
+          <a:effectRef idx="2">
+            <a:schemeClr val="accent1"/>
+          </a:effectRef>
+          <a:fontRef idx="minor">
+            <a:schemeClr val="lt1"/>
+          </a:fontRef>
+        </p:style>
+        <p:txBody>
+          <a:bodyPr rtlCol="0" anchor="ctr"/>
+          <a:lstStyle/>
+          <a:p>
+            <a:pPr algn="ctr"/>
+          </a:p>
+        </p:txBody>
+      </p:sp>
+      <p:sp>
+        <p:nvSpPr>
+          <p:cNvPr id="15" name="TextBox 14"/>
+          <p:cNvSpPr txBox="1"/>
+          <p:nvPr/>
+        </p:nvSpPr>
+        <p:spPr>
+          <a:xfrm>
+            <a:off x="868680" y="4690871"/>
+            <a:ext cx="1463040" cy="502920"/>
+          </a:xfrm>
+          <a:prstGeom prst="rect">
+            <a:avLst/>
+          </a:prstGeom>
+          <a:noFill/>
+        </p:spPr>
+        <p:txBody>
+          <a:bodyPr wrap="square">
+            <a:spAutoFit/>
+          </a:bodyPr>
+          <a:lstStyle/>
+          <a:p>
+            <a:pPr algn="l"/>
+            <a:r>
+              <a:rPr sz="1800" b="1">
+                <a:solidFill>
+                  <a:srgbClr val="FFD60A"/>
+                </a:solidFill>
+                <a:latin typeface="Calibri"/>
+              </a:rPr>
+              <a:t>BONUS</a:t>
+            </a:r>
+          </a:p>
+        </p:txBody>
+      </p:sp>
+      <p:sp>
+        <p:nvSpPr>
+          <p:cNvPr id="16" name="TextBox 15"/>
+          <p:cNvSpPr txBox="1"/>
+          <p:nvPr/>
+        </p:nvSpPr>
+        <p:spPr>
+          <a:xfrm>
+            <a:off x="2286000" y="4690871"/>
+            <a:ext cx="5852160" cy="502920"/>
+          </a:xfrm>
+          <a:prstGeom prst="rect">
+            <a:avLst/>
+          </a:prstGeom>
+          <a:noFill/>
+        </p:spPr>
+        <p:txBody>
+          <a:bodyPr wrap="square">
+            <a:spAutoFit/>
+          </a:bodyPr>
+          <a:lstStyle/>
+          <a:p>
+            <a:pPr algn="l"/>
+            <a:r>
+              <a:rPr sz="1700" b="0">
+                <a:solidFill>
+                  <a:srgbClr val="FAFAFA"/>
+                </a:solidFill>
+                <a:latin typeface="Calibri"/>
+              </a:rPr>
+              <a:t>Change the title field, then save. Open the PDF — does the title match?</a:t>
+            </a:r>
+          </a:p>
+        </p:txBody>
+      </p:sp>
+      <p:pic>
+        <p:nvPicPr>
+          <p:cNvPr id="17" name="Picture 16" descr="sandbox-qr.png"/>
+          <p:cNvPicPr>
+            <a:picLocks noChangeAspect="1"/>
+          </p:cNvPicPr>
+          <p:nvPr/>
+        </p:nvPicPr>
+        <p:blipFill>
+          <a:blip r:embed="rId2"/>
+          <a:stretch>
+            <a:fillRect/>
+          </a:stretch>
+        </p:blipFill>
+        <p:spPr>
+          <a:xfrm>
+            <a:off x="8595360" y="1828800"/>
+            <a:ext cx="3108960" cy="3108960"/>
+          </a:xfrm>
+          <a:prstGeom prst="rect">
+            <a:avLst/>
+          </a:prstGeom>
+        </p:spPr>
+      </p:pic>
+      <p:sp>
+        <p:nvSpPr>
+          <p:cNvPr id="18" name="TextBox 17"/>
+          <p:cNvSpPr txBox="1"/>
+          <p:nvPr/>
+        </p:nvSpPr>
+        <p:spPr>
+          <a:xfrm>
+            <a:off x="8412480" y="5029200"/>
+            <a:ext cx="3566160" cy="457200"/>
+          </a:xfrm>
+          <a:prstGeom prst="rect">
+            <a:avLst/>
+          </a:prstGeom>
+          <a:noFill/>
+        </p:spPr>
+        <p:txBody>
+          <a:bodyPr wrap="square">
+            <a:spAutoFit/>
+          </a:bodyPr>
+          <a:lstStyle/>
+          <a:p>
+            <a:pPr algn="ctr"/>
+            <a:r>
+              <a:rPr sz="1400" b="1">
+                <a:solidFill>
+                  <a:srgbClr val="FFD60A"/>
+                </a:solidFill>
+                <a:latin typeface="Calibri"/>
+              </a:rPr>
+              <a:t>Scan to open</a:t>
+            </a:r>
+          </a:p>
+        </p:txBody>
+      </p:sp>
+      <p:sp>
+        <p:nvSpPr>
+          <p:cNvPr id="19" name="TextBox 18"/>
+          <p:cNvSpPr txBox="1"/>
+          <p:nvPr/>
+        </p:nvSpPr>
+        <p:spPr>
+          <a:xfrm>
+            <a:off x="8412480" y="5349240"/>
+            <a:ext cx="3566160" cy="457200"/>
+          </a:xfrm>
+          <a:prstGeom prst="rect">
+            <a:avLst/>
+          </a:prstGeom>
+          <a:noFill/>
+        </p:spPr>
+        <p:txBody>
+          <a:bodyPr wrap="square">
+            <a:spAutoFit/>
+          </a:bodyPr>
+          <a:lstStyle/>
+          <a:p>
+            <a:pPr algn="ctr"/>
+            <a:r>
+              <a:rPr sz="1500" b="1">
+                <a:solidFill>
+                  <a:srgbClr val="FAFAFA"/>
+                </a:solidFill>
+                <a:latin typeface="Calibri"/>
+              </a:rPr>
+              <a:t>babbled-wear/sandbox</a:t>
+            </a:r>
+          </a:p>
+        </p:txBody>
+      </p:sp>
+      <p:sp>
+        <p:nvSpPr>
+          <p:cNvPr id="20" name="TextBox 19"/>
+          <p:cNvSpPr txBox="1"/>
+          <p:nvPr/>
+        </p:nvSpPr>
+        <p:spPr>
+          <a:xfrm>
+            <a:off x="640080" y="6126480"/>
+            <a:ext cx="10972800" cy="457200"/>
+          </a:xfrm>
+          <a:prstGeom prst="rect">
+            <a:avLst/>
+          </a:prstGeom>
+          <a:noFill/>
+        </p:spPr>
+        <p:txBody>
+          <a:bodyPr wrap="square">
+            <a:spAutoFit/>
+          </a:bodyPr>
+          <a:lstStyle/>
+          <a:p>
+            <a:pPr algn="l"/>
+            <a:r>
+              <a:rPr sz="1600" b="0">
+                <a:solidFill>
+                  <a:srgbClr val="FAFAFA"/>
+                </a:solidFill>
+                <a:latin typeface="Calibri"/>
+              </a:rPr>
+              <a:t>Stuck? Raise your hand — I'll come help.</a:t>
             </a:r>
           </a:p>
         </p:txBody>

</xml_diff>